<commit_message>
docs: refine final presentation
- correct metadata: Timon Fricke, HHZ, "Applied Machine Learning" (not a thesis).
- reframe results as the two method duels (C vs L, S vs H); add a
  "Methode 2: grounding that doesn't hold" slide (S 0.66/42s vs H 0.47/221s —
  H ignores its 212 catalog locators and hallucinates names).
- sharpen findings: live beats static, green≠good, grounding needs enforcement.

Co-Authored-By: Claude Opus 4.8 <noreply@anthropic.com>
</commit_message>
<xml_diff>
--- a/presentation/Endpraesentation_LLM_vs_Crawler.pptx
+++ b/presentation/Endpraesentation_LLM_vs_Crawler.pptx
@@ -21,9 +21,10 @@
     <p:sldId id="269" r:id="rId15"/>
     <p:sldId id="270" r:id="rId16"/>
     <p:sldId id="271" r:id="rId17"/>
+    <p:sldId id="272" r:id="rId18"/>
   </p:sldIdLst>
   <p:notesMasterIdLst>
-    <p:notesMasterId r:id="rId18"/>
+    <p:notesMasterId r:id="rId19"/>
   </p:notesMasterIdLst>
   <p:sldSz cx="12192000" cy="6858000"/>
   <p:notesSz cx="6858000" cy="12192000"/>
@@ -1450,6 +1451,94 @@
             <a:fld id="{F7021451-1387-4CA6-816F-3879F97B5CBC}" type="slidenum">
               <a:rPr lang="en-US"/>
               <a:t>16</a:t>
+            </a:fld>
+            <a:endParaRPr lang="en-US"/>
+          </a:p>
+        </p:txBody>
+      </p:sp>
+    </p:spTree>
+    <p:extLst>
+      <p:ext uri="{BB962C8B-B14F-4D97-AF65-F5344CB8AC3E}">
+        <p14:creationId xmlns:p14="http://schemas.microsoft.com/office/powerpoint/2010/main" val="1024086991"/>
+      </p:ext>
+    </p:extLst>
+  </p:cSld>
+  <p:clrMapOvr>
+    <a:masterClrMapping/>
+  </p:clrMapOvr>
+</p:notes>
+</file>
+
+<file path=ppt/notesSlides/notesSlide17.xml><?xml version="1.0" encoding="utf-8"?>
+<p:notes xmlns:a="http://schemas.openxmlformats.org/drawingml/2006/main" xmlns:r="http://schemas.openxmlformats.org/officeDocument/2006/relationships" xmlns:p="http://schemas.openxmlformats.org/presentationml/2006/main">
+  <p:cSld>
+    <p:spTree>
+      <p:nvGrpSpPr>
+        <p:cNvPr id="1" name=""/>
+        <p:cNvGrpSpPr/>
+        <p:nvPr/>
+      </p:nvGrpSpPr>
+      <p:grpSpPr>
+        <a:xfrm>
+          <a:off x="0" y="0"/>
+          <a:ext cx="0" cy="0"/>
+          <a:chOff x="0" y="0"/>
+          <a:chExt cx="0" cy="0"/>
+        </a:xfrm>
+      </p:grpSpPr>
+      <p:sp>
+        <p:nvSpPr>
+          <p:cNvPr id="2" name="Slide Image Placeholder 1"/>
+          <p:cNvSpPr>
+            <a:spLocks noGrp="1" noRot="1" noChangeAspect="1"/>
+          </p:cNvSpPr>
+          <p:nvPr>
+            <p:ph type="sldImg"/>
+          </p:nvPr>
+        </p:nvSpPr>
+        <p:spPr/>
+      </p:sp>
+      <p:sp>
+        <p:nvSpPr>
+          <p:cNvPr id="3" name="Notes Placeholder 2"/>
+          <p:cNvSpPr>
+            <a:spLocks noGrp="1"/>
+          </p:cNvSpPr>
+          <p:nvPr>
+            <p:ph type="body" idx="1"/>
+          </p:nvPr>
+        </p:nvSpPr>
+        <p:spPr/>
+        <p:txBody>
+          <a:bodyPr/>
+          <a:lstStyle/>
+          <a:p>
+            <a:r>
+              <a:rPr lang="en-US" dirty="0"/>
+              <a:t/>
+            </a:r>
+            <a:endParaRPr lang="en-US" dirty="0"/>
+          </a:p>
+        </p:txBody>
+      </p:sp>
+      <p:sp>
+        <p:nvSpPr>
+          <p:cNvPr id="4" name="Slide Number Placeholder 3"/>
+          <p:cNvSpPr>
+            <a:spLocks noGrp="1"/>
+          </p:cNvSpPr>
+          <p:nvPr>
+            <p:ph type="sldNum" sz="quarter" idx="10"/>
+          </p:nvPr>
+        </p:nvSpPr>
+        <p:spPr/>
+        <p:txBody>
+          <a:bodyPr/>
+          <a:lstStyle/>
+          <a:p>
+            <a:fld id="{F7021451-1387-4CA6-816F-3879F97B5CBC}" type="slidenum">
+              <a:rPr lang="en-US"/>
+              <a:t>17</a:t>
             </a:fld>
             <a:endParaRPr lang="en-US"/>
           </a:p>
@@ -2536,7 +2625,7 @@
                 <a:ea typeface="Courier New" pitchFamily="34" charset="-122"/>
                 <a:cs typeface="Courier New" pitchFamily="34" charset="-120"/>
               </a:rPr>
-              <a:t>Bachelorarbeit · Hochschule Reutlingen · 15.07.2026</a:t>
+              <a:t>Applied Machine Learning · HHZ · 15.07.2026</a:t>
             </a:r>
             <a:endParaRPr lang="en-US" sz="1200" dirty="0"/>
           </a:p>
@@ -2679,7 +2768,7 @@
                 <a:ea typeface="Calibri" pitchFamily="34" charset="-122"/>
                 <a:cs typeface="Calibri" pitchFamily="34" charset="-120"/>
               </a:rPr>
-              <a:t>Erik Fricke · Philippos Melikidis</a:t>
+              <a:t>Timon Fricke · Philippos Melikidis</a:t>
             </a:r>
             <a:endParaRPr lang="en-US" sz="1500" dirty="0"/>
           </a:p>
@@ -4158,7 +4247,7 @@
                 <a:ea typeface="Calibri" pitchFamily="34" charset="-122"/>
                 <a:cs typeface="Calibri" pitchFamily="34" charset="-120"/>
               </a:rPr>
-              <a:t>L schlägt C</a:t>
+              <a:t>Methode 1 · C vs L</a:t>
             </a:r>
             <a:endParaRPr lang="en-US" sz="1500" dirty="0"/>
           </a:p>
@@ -4200,7 +4289,7 @@
                 <a:ea typeface="Calibri" pitchFamily="34" charset="-122"/>
                 <a:cs typeface="Calibri" pitchFamily="34" charset="-120"/>
               </a:rPr>
-              <a:t>0.71 vs. 0.60 — der reine LLM-Agent liegt klar vorn.</a:t>
+              <a:t>Der LLM-Agent führt klar: 0.71 vs. 0.60.</a:t>
             </a:r>
             <a:endParaRPr lang="en-US" sz="1250" dirty="0"/>
           </a:p>
@@ -4239,7 +4328,7 @@
                 <a:ea typeface="Calibri" pitchFamily="34" charset="-122"/>
                 <a:cs typeface="Calibri" pitchFamily="34" charset="-120"/>
               </a:rPr>
-              <a:t>H gewinnt nicht</a:t>
+              <a:t>Methode 2 · S vs H</a:t>
             </a:r>
             <a:endParaRPr lang="en-US" sz="1500" dirty="0"/>
           </a:p>
@@ -4281,7 +4370,7 @@
                 <a:ea typeface="Calibri" pitchFamily="34" charset="-122"/>
                 <a:cs typeface="Calibri" pitchFamily="34" charset="-120"/>
               </a:rPr>
-              <a:t>Der Hybrid landet nur auf Crawler-Niveau (0.60).</a:t>
+              <a:t>Live-DOM (S 0.66) schlägt Crawler-Map (H 0.60).</a:t>
             </a:r>
             <a:endParaRPr lang="en-US" sz="1250" dirty="0"/>
           </a:p>
@@ -4320,7 +4409,7 @@
                 <a:ea typeface="Calibri" pitchFamily="34" charset="-122"/>
                 <a:cs typeface="Calibri" pitchFamily="34" charset="-120"/>
               </a:rPr>
-              <a:t>Story hilft L nicht</a:t>
+              <a:t>Live schlägt statisch</a:t>
             </a:r>
             <a:endParaRPr lang="en-US" sz="1500" dirty="0"/>
           </a:p>
@@ -4362,7 +4451,7 @@
                 <a:ea typeface="Calibri" pitchFamily="34" charset="-122"/>
                 <a:cs typeface="Calibri" pitchFamily="34" charset="-120"/>
               </a:rPr>
-              <a:t>S (0.66) liegt unter L (0.71).</a:t>
+              <a:t>Beide Duelle gehen an die live erkundenden Agenten.</a:t>
             </a:r>
             <a:endParaRPr lang="en-US" sz="1250" dirty="0"/>
           </a:p>
@@ -4433,7 +4522,7 @@
                 <a:ea typeface="Courier New" pitchFamily="34" charset="-122"/>
                 <a:cs typeface="Courier New" pitchFamily="34" charset="-120"/>
               </a:rPr>
-              <a:t>DIE ENTSCHEIDENDE NUANCE</a:t>
+              <a:t>METHODE 2 · HYBRID IM DETAIL</a:t>
             </a:r>
             <a:endParaRPr lang="en-US" sz="1100" dirty="0"/>
           </a:p>
@@ -4472,7 +4561,7 @@
                 <a:ea typeface="Cambria" pitchFamily="34" charset="-122"/>
                 <a:cs typeface="Cambria" pitchFamily="34" charset="-120"/>
               </a:rPr>
-              <a:t>100 % grün heißt nicht: gute Tests</a:t>
+              <a:t>Grounding, das nicht greift</a:t>
             </a:r>
             <a:endParaRPr lang="en-US" sz="3000" dirty="0"/>
           </a:p>
@@ -4529,7 +4618,7 @@
             </a:avLst>
           </a:prstGeom>
           <a:solidFill>
-            <a:srgbClr val="7A8794"/>
+            <a:srgbClr val="E0912F"/>
           </a:solidFill>
           <a:ln/>
           <a:effectLst>
@@ -4574,7 +4663,7 @@
                 <a:ea typeface="Courier New" pitchFamily="34" charset="-122"/>
                 <a:cs typeface="Courier New" pitchFamily="34" charset="-120"/>
               </a:rPr>
-              <a:t>Skript_C</a:t>
+              <a:t>Skript_S</a:t>
             </a:r>
             <a:endParaRPr lang="en-US" sz="1300" dirty="0"/>
           </a:p>
@@ -4613,7 +4702,7 @@
                 <a:ea typeface="Calibri" pitchFamily="34" charset="-122"/>
                 <a:cs typeface="Calibri" pitchFamily="34" charset="-120"/>
               </a:rPr>
-              <a:t>Crawler</a:t>
+              <a:t>LLM-Agent+Story</a:t>
             </a:r>
             <a:endParaRPr lang="en-US" sz="1400" dirty="0"/>
           </a:p>
@@ -4644,17 +4733,17 @@
               <a:buNone/>
             </a:pPr>
             <a:r>
-              <a:rPr lang="en-US" sz="5800" b="1" dirty="0">
-                <a:solidFill>
-                  <a:srgbClr val="7A8794"/>
+              <a:rPr lang="en-US" sz="5400" b="1" dirty="0">
+                <a:solidFill>
+                  <a:srgbClr val="E0912F"/>
                 </a:solidFill>
                 <a:latin typeface="Cambria" pitchFamily="34" charset="0"/>
                 <a:ea typeface="Cambria" pitchFamily="34" charset="-122"/>
                 <a:cs typeface="Cambria" pitchFamily="34" charset="-120"/>
               </a:rPr>
-              <a:t>1.00</a:t>
-            </a:r>
-            <a:endParaRPr lang="en-US" sz="5800" dirty="0"/>
+              <a:t>0.66</a:t>
+            </a:r>
+            <a:endParaRPr lang="en-US" sz="5400" dirty="0"/>
           </a:p>
         </p:txBody>
       </p:sp>
@@ -4666,24 +4755,24 @@
         </p:nvSpPr>
         <p:spPr>
           <a:xfrm>
-            <a:off x="914400" y="3703320"/>
-            <a:ext cx="2468880" cy="274320"/>
-          </a:xfrm>
-          <a:prstGeom prst="rect">
-            <a:avLst/>
-          </a:prstGeom>
-          <a:noFill/>
-          <a:ln/>
-        </p:spPr>
-        <p:txBody>
-          <a:bodyPr wrap="square" lIns="0" tIns="0" rIns="0" bIns="0" rtlCol="0" anchor="ctr"/>
-          <a:lstStyle/>
-          <a:p>
-            <a:pPr indent="0" marL="0">
-              <a:buNone/>
-            </a:pPr>
-            <a:r>
-              <a:rPr lang="en-US" sz="1250" dirty="0">
+            <a:off x="914400" y="3675888"/>
+            <a:ext cx="2514600" cy="274320"/>
+          </a:xfrm>
+          <a:prstGeom prst="rect">
+            <a:avLst/>
+          </a:prstGeom>
+          <a:noFill/>
+          <a:ln/>
+        </p:spPr>
+        <p:txBody>
+          <a:bodyPr wrap="square" lIns="0" tIns="0" rIns="0" bIns="0" rtlCol="0" anchor="ctr"/>
+          <a:lstStyle/>
+          <a:p>
+            <a:pPr indent="0" marL="0">
+              <a:buNone/>
+            </a:pPr>
+            <a:r>
+              <a:rPr lang="en-US" sz="1200" dirty="0">
                 <a:solidFill>
                   <a:srgbClr val="6B7683"/>
                 </a:solidFill>
@@ -4691,9 +4780,9 @@
                 <a:ea typeface="Calibri" pitchFamily="34" charset="-122"/>
                 <a:cs typeface="Calibri" pitchFamily="34" charset="-120"/>
               </a:rPr>
-              <a:t>Pass-Rate (SSR)</a:t>
-            </a:r>
-            <a:endParaRPr lang="en-US" sz="1250" dirty="0"/>
+              <a:t>Functional Suitability</a:t>
+            </a:r>
+            <a:endParaRPr lang="en-US" sz="1200" dirty="0"/>
           </a:p>
         </p:txBody>
       </p:sp>
@@ -4705,7 +4794,7 @@
         </p:nvSpPr>
         <p:spPr>
           <a:xfrm>
-            <a:off x="3520440" y="2697480"/>
+            <a:off x="3566160" y="2697480"/>
             <a:ext cx="2194560" cy="914400"/>
           </a:xfrm>
           <a:prstGeom prst="rect">
@@ -4722,7 +4811,7 @@
               <a:buNone/>
             </a:pPr>
             <a:r>
-              <a:rPr lang="en-US" sz="5800" b="1" dirty="0">
+              <a:rPr lang="en-US" sz="5400" b="1" dirty="0">
                 <a:solidFill>
                   <a:srgbClr val="17202B"/>
                 </a:solidFill>
@@ -4730,9 +4819,9 @@
                 <a:ea typeface="Cambria" pitchFamily="34" charset="-122"/>
                 <a:cs typeface="Cambria" pitchFamily="34" charset="-120"/>
               </a:rPr>
-              <a:t>0.40</a:t>
-            </a:r>
-            <a:endParaRPr lang="en-US" sz="5800" dirty="0"/>
+              <a:t>42 s</a:t>
+            </a:r>
+            <a:endParaRPr lang="en-US" sz="5400" dirty="0"/>
           </a:p>
         </p:txBody>
       </p:sp>
@@ -4744,24 +4833,24 @@
         </p:nvSpPr>
         <p:spPr>
           <a:xfrm>
-            <a:off x="3520440" y="3703320"/>
-            <a:ext cx="2286000" cy="274320"/>
-          </a:xfrm>
-          <a:prstGeom prst="rect">
-            <a:avLst/>
-          </a:prstGeom>
-          <a:noFill/>
-          <a:ln/>
-        </p:spPr>
-        <p:txBody>
-          <a:bodyPr wrap="square" lIns="0" tIns="0" rIns="0" bIns="0" rtlCol="0" anchor="ctr"/>
-          <a:lstStyle/>
-          <a:p>
-            <a:pPr indent="0" marL="0">
-              <a:buNone/>
-            </a:pPr>
-            <a:r>
-              <a:rPr lang="en-US" sz="1250" dirty="0">
+            <a:off x="3566160" y="3675888"/>
+            <a:ext cx="2148840" cy="274320"/>
+          </a:xfrm>
+          <a:prstGeom prst="rect">
+            <a:avLst/>
+          </a:prstGeom>
+          <a:noFill/>
+          <a:ln/>
+        </p:spPr>
+        <p:txBody>
+          <a:bodyPr wrap="square" lIns="0" tIns="0" rIns="0" bIns="0" rtlCol="0" anchor="ctr"/>
+          <a:lstStyle/>
+          <a:p>
+            <a:pPr indent="0" marL="0">
+              <a:buNone/>
+            </a:pPr>
+            <a:r>
+              <a:rPr lang="en-US" sz="1200" dirty="0">
                 <a:solidFill>
                   <a:srgbClr val="6B7683"/>
                 </a:solidFill>
@@ -4769,9 +4858,9 @@
                 <a:ea typeface="Calibri" pitchFamily="34" charset="-122"/>
                 <a:cs typeface="Calibri" pitchFamily="34" charset="-120"/>
               </a:rPr>
-              <a:t>Appropriateness</a:t>
-            </a:r>
-            <a:endParaRPr lang="en-US" sz="1250" dirty="0"/>
+              <a:t>Gen-Zeit</a:t>
+            </a:r>
+            <a:endParaRPr lang="en-US" sz="1200" dirty="0"/>
           </a:p>
         </p:txBody>
       </p:sp>
@@ -4783,8 +4872,8 @@
         </p:nvSpPr>
         <p:spPr>
           <a:xfrm>
-            <a:off x="914400" y="4160520"/>
-            <a:ext cx="4800600" cy="457200"/>
+            <a:off x="914400" y="4114800"/>
+            <a:ext cx="4800600" cy="502920"/>
           </a:xfrm>
           <a:prstGeom prst="rect">
             <a:avLst/>
@@ -4798,22 +4887,22 @@
           <a:p>
             <a:pPr indent="0" marL="0">
               <a:lnSpc>
-                <a:spcPts val="1700"/>
+                <a:spcPts val="1600"/>
               </a:lnSpc>
               <a:buNone/>
             </a:pPr>
             <a:r>
-              <a:rPr lang="en-US" sz="1300" i="1" dirty="0">
-                <a:solidFill>
-                  <a:srgbClr val="7A8794"/>
+              <a:rPr lang="en-US" sz="1250" i="1" dirty="0">
+                <a:solidFill>
+                  <a:srgbClr val="E0912F"/>
                 </a:solidFill>
                 <a:latin typeface="Calibri" pitchFamily="34" charset="0"/>
                 <a:ea typeface="Calibri" pitchFamily="34" charset="-122"/>
                 <a:cs typeface="Calibri" pitchFamily="34" charset="-120"/>
               </a:rPr>
-              <a:t>Immer grün — aber die Prüfungen sind triviale Smoke-Checks.</a:t>
-            </a:r>
-            <a:endParaRPr lang="en-US" sz="1300" dirty="0"/>
+              <a:t>Live-DOM · 3 Seiten beobachtet · bester LLM-SSR (0.55).</a:t>
+            </a:r>
+            <a:endParaRPr lang="en-US" sz="1250" dirty="0"/>
           </a:p>
         </p:txBody>
       </p:sp>
@@ -4868,7 +4957,7 @@
             </a:avLst>
           </a:prstGeom>
           <a:solidFill>
-            <a:srgbClr val="FF5A3C"/>
+            <a:srgbClr val="1FA88F"/>
           </a:solidFill>
           <a:ln/>
           <a:effectLst>
@@ -4913,7 +5002,7 @@
                 <a:ea typeface="Courier New" pitchFamily="34" charset="-122"/>
                 <a:cs typeface="Courier New" pitchFamily="34" charset="-120"/>
               </a:rPr>
-              <a:t>Skript_L</a:t>
+              <a:t>Skript_H</a:t>
             </a:r>
             <a:endParaRPr lang="en-US" sz="1300" dirty="0"/>
           </a:p>
@@ -4952,7 +5041,7 @@
                 <a:ea typeface="Calibri" pitchFamily="34" charset="-122"/>
                 <a:cs typeface="Calibri" pitchFamily="34" charset="-120"/>
               </a:rPr>
-              <a:t>LLM-Agent</a:t>
+              <a:t>Hybrid</a:t>
             </a:r>
             <a:endParaRPr lang="en-US" sz="1400" dirty="0"/>
           </a:p>
@@ -4983,17 +5072,17 @@
               <a:buNone/>
             </a:pPr>
             <a:r>
-              <a:rPr lang="en-US" sz="5800" b="1" dirty="0">
-                <a:solidFill>
-                  <a:srgbClr val="FF5A3C"/>
+              <a:rPr lang="en-US" sz="5400" b="1" dirty="0">
+                <a:solidFill>
+                  <a:srgbClr val="1FA88F"/>
                 </a:solidFill>
                 <a:latin typeface="Cambria" pitchFamily="34" charset="0"/>
                 <a:ea typeface="Cambria" pitchFamily="34" charset="-122"/>
                 <a:cs typeface="Cambria" pitchFamily="34" charset="-120"/>
               </a:rPr>
-              <a:t>0.52</a:t>
-            </a:r>
-            <a:endParaRPr lang="en-US" sz="5800" dirty="0"/>
+              <a:t>0.47</a:t>
+            </a:r>
+            <a:endParaRPr lang="en-US" sz="5400" dirty="0"/>
           </a:p>
         </p:txBody>
       </p:sp>
@@ -5005,24 +5094,24 @@
         </p:nvSpPr>
         <p:spPr>
           <a:xfrm>
-            <a:off x="6446520" y="3703320"/>
-            <a:ext cx="2468880" cy="274320"/>
-          </a:xfrm>
-          <a:prstGeom prst="rect">
-            <a:avLst/>
-          </a:prstGeom>
-          <a:noFill/>
-          <a:ln/>
-        </p:spPr>
-        <p:txBody>
-          <a:bodyPr wrap="square" lIns="0" tIns="0" rIns="0" bIns="0" rtlCol="0" anchor="ctr"/>
-          <a:lstStyle/>
-          <a:p>
-            <a:pPr indent="0" marL="0">
-              <a:buNone/>
-            </a:pPr>
-            <a:r>
-              <a:rPr lang="en-US" sz="1250" dirty="0">
+            <a:off x="6446520" y="3675888"/>
+            <a:ext cx="2514600" cy="274320"/>
+          </a:xfrm>
+          <a:prstGeom prst="rect">
+            <a:avLst/>
+          </a:prstGeom>
+          <a:noFill/>
+          <a:ln/>
+        </p:spPr>
+        <p:txBody>
+          <a:bodyPr wrap="square" lIns="0" tIns="0" rIns="0" bIns="0" rtlCol="0" anchor="ctr"/>
+          <a:lstStyle/>
+          <a:p>
+            <a:pPr indent="0" marL="0">
+              <a:buNone/>
+            </a:pPr>
+            <a:r>
+              <a:rPr lang="en-US" sz="1200" dirty="0">
                 <a:solidFill>
                   <a:srgbClr val="6B7683"/>
                 </a:solidFill>
@@ -5030,9 +5119,9 @@
                 <a:ea typeface="Calibri" pitchFamily="34" charset="-122"/>
                 <a:cs typeface="Calibri" pitchFamily="34" charset="-120"/>
               </a:rPr>
-              <a:t>Pass-Rate (SSR)</a:t>
-            </a:r>
-            <a:endParaRPr lang="en-US" sz="1250" dirty="0"/>
+              <a:t>Functional Suitability</a:t>
+            </a:r>
+            <a:endParaRPr lang="en-US" sz="1200" dirty="0"/>
           </a:p>
         </p:txBody>
       </p:sp>
@@ -5044,7 +5133,7 @@
         </p:nvSpPr>
         <p:spPr>
           <a:xfrm>
-            <a:off x="9052560" y="2697480"/>
+            <a:off x="9098280" y="2697480"/>
             <a:ext cx="2194560" cy="914400"/>
           </a:xfrm>
           <a:prstGeom prst="rect">
@@ -5061,7 +5150,7 @@
               <a:buNone/>
             </a:pPr>
             <a:r>
-              <a:rPr lang="en-US" sz="5800" b="1" dirty="0">
+              <a:rPr lang="en-US" sz="5400" b="1" dirty="0">
                 <a:solidFill>
                   <a:srgbClr val="17202B"/>
                 </a:solidFill>
@@ -5069,9 +5158,9 @@
                 <a:ea typeface="Cambria" pitchFamily="34" charset="-122"/>
                 <a:cs typeface="Cambria" pitchFamily="34" charset="-120"/>
               </a:rPr>
-              <a:t>0.89</a:t>
-            </a:r>
-            <a:endParaRPr lang="en-US" sz="5800" dirty="0"/>
+              <a:t>221 s</a:t>
+            </a:r>
+            <a:endParaRPr lang="en-US" sz="5400" dirty="0"/>
           </a:p>
         </p:txBody>
       </p:sp>
@@ -5083,24 +5172,24 @@
         </p:nvSpPr>
         <p:spPr>
           <a:xfrm>
-            <a:off x="9052560" y="3703320"/>
-            <a:ext cx="2286000" cy="274320"/>
-          </a:xfrm>
-          <a:prstGeom prst="rect">
-            <a:avLst/>
-          </a:prstGeom>
-          <a:noFill/>
-          <a:ln/>
-        </p:spPr>
-        <p:txBody>
-          <a:bodyPr wrap="square" lIns="0" tIns="0" rIns="0" bIns="0" rtlCol="0" anchor="ctr"/>
-          <a:lstStyle/>
-          <a:p>
-            <a:pPr indent="0" marL="0">
-              <a:buNone/>
-            </a:pPr>
-            <a:r>
-              <a:rPr lang="en-US" sz="1250" dirty="0">
+            <a:off x="9098280" y="3675888"/>
+            <a:ext cx="2148840" cy="274320"/>
+          </a:xfrm>
+          <a:prstGeom prst="rect">
+            <a:avLst/>
+          </a:prstGeom>
+          <a:noFill/>
+          <a:ln/>
+        </p:spPr>
+        <p:txBody>
+          <a:bodyPr wrap="square" lIns="0" tIns="0" rIns="0" bIns="0" rtlCol="0" anchor="ctr"/>
+          <a:lstStyle/>
+          <a:p>
+            <a:pPr indent="0" marL="0">
+              <a:buNone/>
+            </a:pPr>
+            <a:r>
+              <a:rPr lang="en-US" sz="1200" dirty="0">
                 <a:solidFill>
                   <a:srgbClr val="6B7683"/>
                 </a:solidFill>
@@ -5108,9 +5197,9 @@
                 <a:ea typeface="Calibri" pitchFamily="34" charset="-122"/>
                 <a:cs typeface="Calibri" pitchFamily="34" charset="-120"/>
               </a:rPr>
-              <a:t>Appropriateness</a:t>
-            </a:r>
-            <a:endParaRPr lang="en-US" sz="1250" dirty="0"/>
+              <a:t>Gen-Zeit</a:t>
+            </a:r>
+            <a:endParaRPr lang="en-US" sz="1200" dirty="0"/>
           </a:p>
         </p:txBody>
       </p:sp>
@@ -5122,8 +5211,8 @@
         </p:nvSpPr>
         <p:spPr>
           <a:xfrm>
-            <a:off x="6446520" y="4160520"/>
-            <a:ext cx="4800600" cy="457200"/>
+            <a:off x="6446520" y="4114800"/>
+            <a:ext cx="4800600" cy="502920"/>
           </a:xfrm>
           <a:prstGeom prst="rect">
             <a:avLst/>
@@ -5137,22 +5226,22 @@
           <a:p>
             <a:pPr indent="0" marL="0">
               <a:lnSpc>
-                <a:spcPts val="1700"/>
+                <a:spcPts val="1600"/>
               </a:lnSpc>
               <a:buNone/>
             </a:pPr>
             <a:r>
-              <a:rPr lang="en-US" sz="1300" i="1" dirty="0">
-                <a:solidFill>
-                  <a:srgbClr val="FF5A3C"/>
+              <a:rPr lang="en-US" sz="1250" i="1" dirty="0">
+                <a:solidFill>
+                  <a:srgbClr val="1FA88F"/>
                 </a:solidFill>
                 <a:latin typeface="Calibri" pitchFamily="34" charset="0"/>
                 <a:ea typeface="Calibri" pitchFamily="34" charset="-122"/>
                 <a:cs typeface="Calibri" pitchFamily="34" charset="-120"/>
               </a:rPr>
-              <a:t>Seltener grün — aber echte, robuste, benutzerorientierte Tests.</a:t>
-            </a:r>
-            <a:endParaRPr lang="en-US" sz="1300" dirty="0"/>
+              <a:t>Crawler-Map · nur 1 Seite live · teuerste UND schwächste.</a:t>
+            </a:r>
+            <a:endParaRPr lang="en-US" sz="1250" dirty="0"/>
           </a:p>
         </p:txBody>
       </p:sp>
@@ -5186,8 +5275,8 @@
         </p:nvSpPr>
         <p:spPr>
           <a:xfrm>
-            <a:off x="914400" y="5193792"/>
-            <a:ext cx="10332720" cy="731520"/>
+            <a:off x="914400" y="5175504"/>
+            <a:ext cx="10332720" cy="777240"/>
           </a:xfrm>
           <a:prstGeom prst="rect">
             <a:avLst/>
@@ -5201,29 +5290,29 @@
           <a:p>
             <a:pPr indent="0" marL="0">
               <a:lnSpc>
-                <a:spcPts val="2000"/>
+                <a:spcPts val="1800"/>
               </a:lnSpc>
               <a:buNone/>
             </a:pPr>
             <a:r>
-              <a:rPr lang="en-US" sz="1450" b="1" dirty="0">
-                <a:solidFill>
-                  <a:srgbClr val="FF5A3C"/>
+              <a:rPr lang="en-US" sz="1350" b="1" dirty="0">
+                <a:solidFill>
+                  <a:srgbClr val="1FA88F"/>
                 </a:solidFill>
                 <a:latin typeface="Calibri" pitchFamily="34" charset="0"/>
                 <a:ea typeface="Calibri" pitchFamily="34" charset="-122"/>
                 <a:cs typeface="Calibri" pitchFamily="34" charset="-120"/>
               </a:rPr>
-              <a:t>Kernpunkt:  </a:t>
+              <a:t>Warum H verliert:  </a:t>
             </a:r>
             <a:pPr indent="0" marL="0">
               <a:lnSpc>
-                <a:spcPts val="2000"/>
+                <a:spcPts val="1800"/>
               </a:lnSpc>
               <a:buNone/>
             </a:pPr>
             <a:r>
-              <a:rPr lang="en-US" sz="1450" dirty="0">
+              <a:rPr lang="en-US" sz="1350" dirty="0">
                 <a:solidFill>
                   <a:srgbClr val="FFFFFF"/>
                 </a:solidFill>
@@ -5231,9 +5320,9 @@
                 <a:ea typeface="Calibri" pitchFamily="34" charset="-122"/>
                 <a:cs typeface="Calibri" pitchFamily="34" charset="-120"/>
               </a:rPr>
-              <a:t>Die Pass-Rate allein täuscht. Der Crawler besteht, weil er kaum etwas prüft; der LLM-Agent riskiert Fehlschläge, weil er echtes Verhalten verifiziert. Erst die ISO-Bewertung macht diesen Unterschied sichtbar.</a:t>
-            </a:r>
-            <a:endParaRPr lang="en-US" sz="1450" dirty="0"/>
+              <a:t>H bekommt 212 verifizierte Crawler-Locator — hält sich aber nicht daran und erfindet Namen („Email address“ statt der echten „Text field for the login email“). Grounding wirkt nur als harte Constraint, nicht als bloßer Kontext.</a:t>
+            </a:r>
+            <a:endParaRPr lang="en-US" sz="1350" dirty="0"/>
           </a:p>
         </p:txBody>
       </p:sp>
@@ -5287,6 +5376,914 @@
 <file path=ppt/slides/slide13.xml><?xml version="1.0" encoding="utf-8"?>
 <p:sld xmlns:a="http://schemas.openxmlformats.org/drawingml/2006/main" xmlns:r="http://schemas.openxmlformats.org/officeDocument/2006/relationships" xmlns:p="http://schemas.openxmlformats.org/presentationml/2006/main">
   <p:cSld name="Slide 13">
+    <p:bg>
+      <p:bgPr>
+        <a:solidFill>
+          <a:srgbClr val="FFFFFF"/>
+        </a:solidFill>
+      </p:bgPr>
+    </p:bg>
+    <p:spTree>
+      <p:nvGrpSpPr>
+        <p:cNvPr id="1" name=""/>
+        <p:cNvGrpSpPr/>
+        <p:nvPr/>
+      </p:nvGrpSpPr>
+      <p:grpSpPr>
+        <a:xfrm>
+          <a:off x="0" y="0"/>
+          <a:ext cx="0" cy="0"/>
+          <a:chOff x="0" y="0"/>
+          <a:chExt cx="0" cy="0"/>
+        </a:xfrm>
+      </p:grpSpPr>
+      <p:sp>
+        <p:nvSpPr>
+          <p:cNvPr id="2" name="Text 0"/>
+          <p:cNvSpPr/>
+          <p:nvPr/>
+        </p:nvSpPr>
+        <p:spPr>
+          <a:xfrm>
+            <a:off x="640080" y="548640"/>
+            <a:ext cx="7315200" cy="274320"/>
+          </a:xfrm>
+          <a:prstGeom prst="rect">
+            <a:avLst/>
+          </a:prstGeom>
+          <a:noFill/>
+          <a:ln/>
+        </p:spPr>
+        <p:txBody>
+          <a:bodyPr wrap="square" lIns="0" tIns="0" rIns="0" bIns="0" rtlCol="0" anchor="ctr"/>
+          <a:lstStyle/>
+          <a:p>
+            <a:pPr indent="0" marL="0">
+              <a:buNone/>
+            </a:pPr>
+            <a:r>
+              <a:rPr lang="en-US" sz="1100" b="1" spc="200" kern="0" dirty="0">
+                <a:solidFill>
+                  <a:srgbClr val="FF5A3C"/>
+                </a:solidFill>
+                <a:latin typeface="Courier New" pitchFamily="34" charset="0"/>
+                <a:ea typeface="Courier New" pitchFamily="34" charset="-122"/>
+                <a:cs typeface="Courier New" pitchFamily="34" charset="-120"/>
+              </a:rPr>
+              <a:t>DIE ENTSCHEIDENDE NUANCE</a:t>
+            </a:r>
+            <a:endParaRPr lang="en-US" sz="1100" dirty="0"/>
+          </a:p>
+        </p:txBody>
+      </p:sp>
+      <p:sp>
+        <p:nvSpPr>
+          <p:cNvPr id="3" name="Text 1"/>
+          <p:cNvSpPr/>
+          <p:nvPr/>
+        </p:nvSpPr>
+        <p:spPr>
+          <a:xfrm>
+            <a:off x="603504" y="868680"/>
+            <a:ext cx="10972800" cy="640080"/>
+          </a:xfrm>
+          <a:prstGeom prst="rect">
+            <a:avLst/>
+          </a:prstGeom>
+          <a:noFill/>
+          <a:ln/>
+        </p:spPr>
+        <p:txBody>
+          <a:bodyPr wrap="square" rtlCol="0" anchor="ctr"/>
+          <a:lstStyle/>
+          <a:p>
+            <a:pPr indent="0" marL="0">
+              <a:buNone/>
+            </a:pPr>
+            <a:r>
+              <a:rPr lang="en-US" sz="3000" b="1" dirty="0">
+                <a:solidFill>
+                  <a:srgbClr val="17202B"/>
+                </a:solidFill>
+                <a:latin typeface="Cambria" pitchFamily="34" charset="0"/>
+                <a:ea typeface="Cambria" pitchFamily="34" charset="-122"/>
+                <a:cs typeface="Cambria" pitchFamily="34" charset="-120"/>
+              </a:rPr>
+              <a:t>100 % grün heißt nicht: gute Tests</a:t>
+            </a:r>
+            <a:endParaRPr lang="en-US" sz="3000" dirty="0"/>
+          </a:p>
+        </p:txBody>
+      </p:sp>
+      <p:sp>
+        <p:nvSpPr>
+          <p:cNvPr id="4" name="Shape 2"/>
+          <p:cNvSpPr/>
+          <p:nvPr/>
+        </p:nvSpPr>
+        <p:spPr>
+          <a:xfrm>
+            <a:off x="640080" y="1874520"/>
+            <a:ext cx="5349240" cy="2880360"/>
+          </a:xfrm>
+          <a:prstGeom prst="roundRect">
+            <a:avLst>
+              <a:gd name="adj" fmla="val 3810"/>
+            </a:avLst>
+          </a:prstGeom>
+          <a:solidFill>
+            <a:srgbClr val="FBFBFC"/>
+          </a:solidFill>
+          <a:ln w="12700">
+            <a:solidFill>
+              <a:srgbClr val="E4E7EB"/>
+            </a:solidFill>
+            <a:prstDash val="solid"/>
+          </a:ln>
+          <a:effectLst>
+            <a:outerShdw sx="100000" sy="100000" kx="0" ky="0" algn="bl" rotWithShape="0" blurRad="114300" dist="38100" dir="5400000">
+              <a:srgbClr val="9AA7B4">
+                <a:alpha val="28000"/>
+              </a:srgbClr>
+            </a:outerShdw>
+          </a:effectLst>
+        </p:spPr>
+      </p:sp>
+      <p:sp>
+        <p:nvSpPr>
+          <p:cNvPr id="5" name="Shape 3"/>
+          <p:cNvSpPr/>
+          <p:nvPr/>
+        </p:nvSpPr>
+        <p:spPr>
+          <a:xfrm>
+            <a:off x="914400" y="2121408"/>
+            <a:ext cx="1417320" cy="384048"/>
+          </a:xfrm>
+          <a:prstGeom prst="roundRect">
+            <a:avLst>
+              <a:gd name="adj" fmla="val 19048"/>
+            </a:avLst>
+          </a:prstGeom>
+          <a:solidFill>
+            <a:srgbClr val="7A8794"/>
+          </a:solidFill>
+          <a:ln/>
+          <a:effectLst>
+            <a:outerShdw sx="100000" sy="100000" kx="0" ky="0" algn="bl" rotWithShape="0" blurRad="114300" dist="38100" dir="5400000">
+              <a:srgbClr val="9AA7B4">
+                <a:alpha val="28000"/>
+              </a:srgbClr>
+            </a:outerShdw>
+          </a:effectLst>
+        </p:spPr>
+      </p:sp>
+      <p:sp>
+        <p:nvSpPr>
+          <p:cNvPr id="6" name="Text 4"/>
+          <p:cNvSpPr/>
+          <p:nvPr/>
+        </p:nvSpPr>
+        <p:spPr>
+          <a:xfrm>
+            <a:off x="914400" y="2121408"/>
+            <a:ext cx="1417320" cy="384048"/>
+          </a:xfrm>
+          <a:prstGeom prst="rect">
+            <a:avLst/>
+          </a:prstGeom>
+          <a:noFill/>
+          <a:ln/>
+        </p:spPr>
+        <p:txBody>
+          <a:bodyPr wrap="square" lIns="0" tIns="0" rIns="0" bIns="0" rtlCol="0" anchor="ctr"/>
+          <a:lstStyle/>
+          <a:p>
+            <a:pPr algn="ctr" indent="0" marL="0">
+              <a:buNone/>
+            </a:pPr>
+            <a:r>
+              <a:rPr lang="en-US" sz="1300" b="1" dirty="0">
+                <a:solidFill>
+                  <a:srgbClr val="FFFFFF"/>
+                </a:solidFill>
+                <a:latin typeface="Courier New" pitchFamily="34" charset="0"/>
+                <a:ea typeface="Courier New" pitchFamily="34" charset="-122"/>
+                <a:cs typeface="Courier New" pitchFamily="34" charset="-120"/>
+              </a:rPr>
+              <a:t>Skript_C</a:t>
+            </a:r>
+            <a:endParaRPr lang="en-US" sz="1300" dirty="0"/>
+          </a:p>
+        </p:txBody>
+      </p:sp>
+      <p:sp>
+        <p:nvSpPr>
+          <p:cNvPr id="7" name="Text 5"/>
+          <p:cNvSpPr/>
+          <p:nvPr/>
+        </p:nvSpPr>
+        <p:spPr>
+          <a:xfrm>
+            <a:off x="2450592" y="2121408"/>
+            <a:ext cx="3291840" cy="384048"/>
+          </a:xfrm>
+          <a:prstGeom prst="rect">
+            <a:avLst/>
+          </a:prstGeom>
+          <a:noFill/>
+          <a:ln/>
+        </p:spPr>
+        <p:txBody>
+          <a:bodyPr wrap="square" lIns="0" tIns="0" rIns="0" bIns="0" rtlCol="0" anchor="ctr"/>
+          <a:lstStyle/>
+          <a:p>
+            <a:pPr indent="0" marL="0">
+              <a:buNone/>
+            </a:pPr>
+            <a:r>
+              <a:rPr lang="en-US" sz="1400" b="1" dirty="0">
+                <a:solidFill>
+                  <a:srgbClr val="17202B"/>
+                </a:solidFill>
+                <a:latin typeface="Calibri" pitchFamily="34" charset="0"/>
+                <a:ea typeface="Calibri" pitchFamily="34" charset="-122"/>
+                <a:cs typeface="Calibri" pitchFamily="34" charset="-120"/>
+              </a:rPr>
+              <a:t>Crawler</a:t>
+            </a:r>
+            <a:endParaRPr lang="en-US" sz="1400" dirty="0"/>
+          </a:p>
+        </p:txBody>
+      </p:sp>
+      <p:sp>
+        <p:nvSpPr>
+          <p:cNvPr id="8" name="Text 6"/>
+          <p:cNvSpPr/>
+          <p:nvPr/>
+        </p:nvSpPr>
+        <p:spPr>
+          <a:xfrm>
+            <a:off x="914400" y="2697480"/>
+            <a:ext cx="2468880" cy="914400"/>
+          </a:xfrm>
+          <a:prstGeom prst="rect">
+            <a:avLst/>
+          </a:prstGeom>
+          <a:noFill/>
+          <a:ln/>
+        </p:spPr>
+        <p:txBody>
+          <a:bodyPr wrap="square" lIns="0" tIns="0" rIns="0" bIns="0" rtlCol="0" anchor="ctr"/>
+          <a:lstStyle/>
+          <a:p>
+            <a:pPr indent="0" marL="0">
+              <a:buNone/>
+            </a:pPr>
+            <a:r>
+              <a:rPr lang="en-US" sz="5800" b="1" dirty="0">
+                <a:solidFill>
+                  <a:srgbClr val="7A8794"/>
+                </a:solidFill>
+                <a:latin typeface="Cambria" pitchFamily="34" charset="0"/>
+                <a:ea typeface="Cambria" pitchFamily="34" charset="-122"/>
+                <a:cs typeface="Cambria" pitchFamily="34" charset="-120"/>
+              </a:rPr>
+              <a:t>1.00</a:t>
+            </a:r>
+            <a:endParaRPr lang="en-US" sz="5800" dirty="0"/>
+          </a:p>
+        </p:txBody>
+      </p:sp>
+      <p:sp>
+        <p:nvSpPr>
+          <p:cNvPr id="9" name="Text 7"/>
+          <p:cNvSpPr/>
+          <p:nvPr/>
+        </p:nvSpPr>
+        <p:spPr>
+          <a:xfrm>
+            <a:off x="914400" y="3703320"/>
+            <a:ext cx="2468880" cy="274320"/>
+          </a:xfrm>
+          <a:prstGeom prst="rect">
+            <a:avLst/>
+          </a:prstGeom>
+          <a:noFill/>
+          <a:ln/>
+        </p:spPr>
+        <p:txBody>
+          <a:bodyPr wrap="square" lIns="0" tIns="0" rIns="0" bIns="0" rtlCol="0" anchor="ctr"/>
+          <a:lstStyle/>
+          <a:p>
+            <a:pPr indent="0" marL="0">
+              <a:buNone/>
+            </a:pPr>
+            <a:r>
+              <a:rPr lang="en-US" sz="1250" dirty="0">
+                <a:solidFill>
+                  <a:srgbClr val="6B7683"/>
+                </a:solidFill>
+                <a:latin typeface="Calibri" pitchFamily="34" charset="0"/>
+                <a:ea typeface="Calibri" pitchFamily="34" charset="-122"/>
+                <a:cs typeface="Calibri" pitchFamily="34" charset="-120"/>
+              </a:rPr>
+              <a:t>Pass-Rate (SSR)</a:t>
+            </a:r>
+            <a:endParaRPr lang="en-US" sz="1250" dirty="0"/>
+          </a:p>
+        </p:txBody>
+      </p:sp>
+      <p:sp>
+        <p:nvSpPr>
+          <p:cNvPr id="10" name="Text 8"/>
+          <p:cNvSpPr/>
+          <p:nvPr/>
+        </p:nvSpPr>
+        <p:spPr>
+          <a:xfrm>
+            <a:off x="3520440" y="2697480"/>
+            <a:ext cx="2194560" cy="914400"/>
+          </a:xfrm>
+          <a:prstGeom prst="rect">
+            <a:avLst/>
+          </a:prstGeom>
+          <a:noFill/>
+          <a:ln/>
+        </p:spPr>
+        <p:txBody>
+          <a:bodyPr wrap="square" lIns="0" tIns="0" rIns="0" bIns="0" rtlCol="0" anchor="ctr"/>
+          <a:lstStyle/>
+          <a:p>
+            <a:pPr indent="0" marL="0">
+              <a:buNone/>
+            </a:pPr>
+            <a:r>
+              <a:rPr lang="en-US" sz="5800" b="1" dirty="0">
+                <a:solidFill>
+                  <a:srgbClr val="17202B"/>
+                </a:solidFill>
+                <a:latin typeface="Cambria" pitchFamily="34" charset="0"/>
+                <a:ea typeface="Cambria" pitchFamily="34" charset="-122"/>
+                <a:cs typeface="Cambria" pitchFamily="34" charset="-120"/>
+              </a:rPr>
+              <a:t>0.40</a:t>
+            </a:r>
+            <a:endParaRPr lang="en-US" sz="5800" dirty="0"/>
+          </a:p>
+        </p:txBody>
+      </p:sp>
+      <p:sp>
+        <p:nvSpPr>
+          <p:cNvPr id="11" name="Text 9"/>
+          <p:cNvSpPr/>
+          <p:nvPr/>
+        </p:nvSpPr>
+        <p:spPr>
+          <a:xfrm>
+            <a:off x="3520440" y="3703320"/>
+            <a:ext cx="2286000" cy="274320"/>
+          </a:xfrm>
+          <a:prstGeom prst="rect">
+            <a:avLst/>
+          </a:prstGeom>
+          <a:noFill/>
+          <a:ln/>
+        </p:spPr>
+        <p:txBody>
+          <a:bodyPr wrap="square" lIns="0" tIns="0" rIns="0" bIns="0" rtlCol="0" anchor="ctr"/>
+          <a:lstStyle/>
+          <a:p>
+            <a:pPr indent="0" marL="0">
+              <a:buNone/>
+            </a:pPr>
+            <a:r>
+              <a:rPr lang="en-US" sz="1250" dirty="0">
+                <a:solidFill>
+                  <a:srgbClr val="6B7683"/>
+                </a:solidFill>
+                <a:latin typeface="Calibri" pitchFamily="34" charset="0"/>
+                <a:ea typeface="Calibri" pitchFamily="34" charset="-122"/>
+                <a:cs typeface="Calibri" pitchFamily="34" charset="-120"/>
+              </a:rPr>
+              <a:t>Appropriateness</a:t>
+            </a:r>
+            <a:endParaRPr lang="en-US" sz="1250" dirty="0"/>
+          </a:p>
+        </p:txBody>
+      </p:sp>
+      <p:sp>
+        <p:nvSpPr>
+          <p:cNvPr id="12" name="Text 10"/>
+          <p:cNvSpPr/>
+          <p:nvPr/>
+        </p:nvSpPr>
+        <p:spPr>
+          <a:xfrm>
+            <a:off x="914400" y="4160520"/>
+            <a:ext cx="4800600" cy="457200"/>
+          </a:xfrm>
+          <a:prstGeom prst="rect">
+            <a:avLst/>
+          </a:prstGeom>
+          <a:noFill/>
+          <a:ln/>
+        </p:spPr>
+        <p:txBody>
+          <a:bodyPr wrap="square" lIns="0" tIns="0" rIns="0" bIns="0" rtlCol="0" anchor="ctr"/>
+          <a:lstStyle/>
+          <a:p>
+            <a:pPr indent="0" marL="0">
+              <a:lnSpc>
+                <a:spcPts val="1700"/>
+              </a:lnSpc>
+              <a:buNone/>
+            </a:pPr>
+            <a:r>
+              <a:rPr lang="en-US" sz="1300" i="1" dirty="0">
+                <a:solidFill>
+                  <a:srgbClr val="7A8794"/>
+                </a:solidFill>
+                <a:latin typeface="Calibri" pitchFamily="34" charset="0"/>
+                <a:ea typeface="Calibri" pitchFamily="34" charset="-122"/>
+                <a:cs typeface="Calibri" pitchFamily="34" charset="-120"/>
+              </a:rPr>
+              <a:t>Immer grün — aber die Prüfungen sind triviale Smoke-Checks.</a:t>
+            </a:r>
+            <a:endParaRPr lang="en-US" sz="1300" dirty="0"/>
+          </a:p>
+        </p:txBody>
+      </p:sp>
+      <p:sp>
+        <p:nvSpPr>
+          <p:cNvPr id="13" name="Shape 11"/>
+          <p:cNvSpPr/>
+          <p:nvPr/>
+        </p:nvSpPr>
+        <p:spPr>
+          <a:xfrm>
+            <a:off x="6172200" y="1874520"/>
+            <a:ext cx="5349240" cy="2880360"/>
+          </a:xfrm>
+          <a:prstGeom prst="roundRect">
+            <a:avLst>
+              <a:gd name="adj" fmla="val 3810"/>
+            </a:avLst>
+          </a:prstGeom>
+          <a:solidFill>
+            <a:srgbClr val="FBFBFC"/>
+          </a:solidFill>
+          <a:ln w="12700">
+            <a:solidFill>
+              <a:srgbClr val="E4E7EB"/>
+            </a:solidFill>
+            <a:prstDash val="solid"/>
+          </a:ln>
+          <a:effectLst>
+            <a:outerShdw sx="100000" sy="100000" kx="0" ky="0" algn="bl" rotWithShape="0" blurRad="114300" dist="38100" dir="5400000">
+              <a:srgbClr val="9AA7B4">
+                <a:alpha val="28000"/>
+              </a:srgbClr>
+            </a:outerShdw>
+          </a:effectLst>
+        </p:spPr>
+      </p:sp>
+      <p:sp>
+        <p:nvSpPr>
+          <p:cNvPr id="14" name="Shape 12"/>
+          <p:cNvSpPr/>
+          <p:nvPr/>
+        </p:nvSpPr>
+        <p:spPr>
+          <a:xfrm>
+            <a:off x="6446520" y="2121408"/>
+            <a:ext cx="1417320" cy="384048"/>
+          </a:xfrm>
+          <a:prstGeom prst="roundRect">
+            <a:avLst>
+              <a:gd name="adj" fmla="val 19048"/>
+            </a:avLst>
+          </a:prstGeom>
+          <a:solidFill>
+            <a:srgbClr val="FF5A3C"/>
+          </a:solidFill>
+          <a:ln/>
+          <a:effectLst>
+            <a:outerShdw sx="100000" sy="100000" kx="0" ky="0" algn="bl" rotWithShape="0" blurRad="114300" dist="38100" dir="5400000">
+              <a:srgbClr val="9AA7B4">
+                <a:alpha val="28000"/>
+              </a:srgbClr>
+            </a:outerShdw>
+          </a:effectLst>
+        </p:spPr>
+      </p:sp>
+      <p:sp>
+        <p:nvSpPr>
+          <p:cNvPr id="15" name="Text 13"/>
+          <p:cNvSpPr/>
+          <p:nvPr/>
+        </p:nvSpPr>
+        <p:spPr>
+          <a:xfrm>
+            <a:off x="6446520" y="2121408"/>
+            <a:ext cx="1417320" cy="384048"/>
+          </a:xfrm>
+          <a:prstGeom prst="rect">
+            <a:avLst/>
+          </a:prstGeom>
+          <a:noFill/>
+          <a:ln/>
+        </p:spPr>
+        <p:txBody>
+          <a:bodyPr wrap="square" lIns="0" tIns="0" rIns="0" bIns="0" rtlCol="0" anchor="ctr"/>
+          <a:lstStyle/>
+          <a:p>
+            <a:pPr algn="ctr" indent="0" marL="0">
+              <a:buNone/>
+            </a:pPr>
+            <a:r>
+              <a:rPr lang="en-US" sz="1300" b="1" dirty="0">
+                <a:solidFill>
+                  <a:srgbClr val="FFFFFF"/>
+                </a:solidFill>
+                <a:latin typeface="Courier New" pitchFamily="34" charset="0"/>
+                <a:ea typeface="Courier New" pitchFamily="34" charset="-122"/>
+                <a:cs typeface="Courier New" pitchFamily="34" charset="-120"/>
+              </a:rPr>
+              <a:t>Skript_L</a:t>
+            </a:r>
+            <a:endParaRPr lang="en-US" sz="1300" dirty="0"/>
+          </a:p>
+        </p:txBody>
+      </p:sp>
+      <p:sp>
+        <p:nvSpPr>
+          <p:cNvPr id="16" name="Text 14"/>
+          <p:cNvSpPr/>
+          <p:nvPr/>
+        </p:nvSpPr>
+        <p:spPr>
+          <a:xfrm>
+            <a:off x="7982712" y="2121408"/>
+            <a:ext cx="3291840" cy="384048"/>
+          </a:xfrm>
+          <a:prstGeom prst="rect">
+            <a:avLst/>
+          </a:prstGeom>
+          <a:noFill/>
+          <a:ln/>
+        </p:spPr>
+        <p:txBody>
+          <a:bodyPr wrap="square" lIns="0" tIns="0" rIns="0" bIns="0" rtlCol="0" anchor="ctr"/>
+          <a:lstStyle/>
+          <a:p>
+            <a:pPr indent="0" marL="0">
+              <a:buNone/>
+            </a:pPr>
+            <a:r>
+              <a:rPr lang="en-US" sz="1400" b="1" dirty="0">
+                <a:solidFill>
+                  <a:srgbClr val="17202B"/>
+                </a:solidFill>
+                <a:latin typeface="Calibri" pitchFamily="34" charset="0"/>
+                <a:ea typeface="Calibri" pitchFamily="34" charset="-122"/>
+                <a:cs typeface="Calibri" pitchFamily="34" charset="-120"/>
+              </a:rPr>
+              <a:t>LLM-Agent</a:t>
+            </a:r>
+            <a:endParaRPr lang="en-US" sz="1400" dirty="0"/>
+          </a:p>
+        </p:txBody>
+      </p:sp>
+      <p:sp>
+        <p:nvSpPr>
+          <p:cNvPr id="17" name="Text 15"/>
+          <p:cNvSpPr/>
+          <p:nvPr/>
+        </p:nvSpPr>
+        <p:spPr>
+          <a:xfrm>
+            <a:off x="6446520" y="2697480"/>
+            <a:ext cx="2468880" cy="914400"/>
+          </a:xfrm>
+          <a:prstGeom prst="rect">
+            <a:avLst/>
+          </a:prstGeom>
+          <a:noFill/>
+          <a:ln/>
+        </p:spPr>
+        <p:txBody>
+          <a:bodyPr wrap="square" lIns="0" tIns="0" rIns="0" bIns="0" rtlCol="0" anchor="ctr"/>
+          <a:lstStyle/>
+          <a:p>
+            <a:pPr indent="0" marL="0">
+              <a:buNone/>
+            </a:pPr>
+            <a:r>
+              <a:rPr lang="en-US" sz="5800" b="1" dirty="0">
+                <a:solidFill>
+                  <a:srgbClr val="FF5A3C"/>
+                </a:solidFill>
+                <a:latin typeface="Cambria" pitchFamily="34" charset="0"/>
+                <a:ea typeface="Cambria" pitchFamily="34" charset="-122"/>
+                <a:cs typeface="Cambria" pitchFamily="34" charset="-120"/>
+              </a:rPr>
+              <a:t>0.52</a:t>
+            </a:r>
+            <a:endParaRPr lang="en-US" sz="5800" dirty="0"/>
+          </a:p>
+        </p:txBody>
+      </p:sp>
+      <p:sp>
+        <p:nvSpPr>
+          <p:cNvPr id="18" name="Text 16"/>
+          <p:cNvSpPr/>
+          <p:nvPr/>
+        </p:nvSpPr>
+        <p:spPr>
+          <a:xfrm>
+            <a:off x="6446520" y="3703320"/>
+            <a:ext cx="2468880" cy="274320"/>
+          </a:xfrm>
+          <a:prstGeom prst="rect">
+            <a:avLst/>
+          </a:prstGeom>
+          <a:noFill/>
+          <a:ln/>
+        </p:spPr>
+        <p:txBody>
+          <a:bodyPr wrap="square" lIns="0" tIns="0" rIns="0" bIns="0" rtlCol="0" anchor="ctr"/>
+          <a:lstStyle/>
+          <a:p>
+            <a:pPr indent="0" marL="0">
+              <a:buNone/>
+            </a:pPr>
+            <a:r>
+              <a:rPr lang="en-US" sz="1250" dirty="0">
+                <a:solidFill>
+                  <a:srgbClr val="6B7683"/>
+                </a:solidFill>
+                <a:latin typeface="Calibri" pitchFamily="34" charset="0"/>
+                <a:ea typeface="Calibri" pitchFamily="34" charset="-122"/>
+                <a:cs typeface="Calibri" pitchFamily="34" charset="-120"/>
+              </a:rPr>
+              <a:t>Pass-Rate (SSR)</a:t>
+            </a:r>
+            <a:endParaRPr lang="en-US" sz="1250" dirty="0"/>
+          </a:p>
+        </p:txBody>
+      </p:sp>
+      <p:sp>
+        <p:nvSpPr>
+          <p:cNvPr id="19" name="Text 17"/>
+          <p:cNvSpPr/>
+          <p:nvPr/>
+        </p:nvSpPr>
+        <p:spPr>
+          <a:xfrm>
+            <a:off x="9052560" y="2697480"/>
+            <a:ext cx="2194560" cy="914400"/>
+          </a:xfrm>
+          <a:prstGeom prst="rect">
+            <a:avLst/>
+          </a:prstGeom>
+          <a:noFill/>
+          <a:ln/>
+        </p:spPr>
+        <p:txBody>
+          <a:bodyPr wrap="square" lIns="0" tIns="0" rIns="0" bIns="0" rtlCol="0" anchor="ctr"/>
+          <a:lstStyle/>
+          <a:p>
+            <a:pPr indent="0" marL="0">
+              <a:buNone/>
+            </a:pPr>
+            <a:r>
+              <a:rPr lang="en-US" sz="5800" b="1" dirty="0">
+                <a:solidFill>
+                  <a:srgbClr val="17202B"/>
+                </a:solidFill>
+                <a:latin typeface="Cambria" pitchFamily="34" charset="0"/>
+                <a:ea typeface="Cambria" pitchFamily="34" charset="-122"/>
+                <a:cs typeface="Cambria" pitchFamily="34" charset="-120"/>
+              </a:rPr>
+              <a:t>0.89</a:t>
+            </a:r>
+            <a:endParaRPr lang="en-US" sz="5800" dirty="0"/>
+          </a:p>
+        </p:txBody>
+      </p:sp>
+      <p:sp>
+        <p:nvSpPr>
+          <p:cNvPr id="20" name="Text 18"/>
+          <p:cNvSpPr/>
+          <p:nvPr/>
+        </p:nvSpPr>
+        <p:spPr>
+          <a:xfrm>
+            <a:off x="9052560" y="3703320"/>
+            <a:ext cx="2286000" cy="274320"/>
+          </a:xfrm>
+          <a:prstGeom prst="rect">
+            <a:avLst/>
+          </a:prstGeom>
+          <a:noFill/>
+          <a:ln/>
+        </p:spPr>
+        <p:txBody>
+          <a:bodyPr wrap="square" lIns="0" tIns="0" rIns="0" bIns="0" rtlCol="0" anchor="ctr"/>
+          <a:lstStyle/>
+          <a:p>
+            <a:pPr indent="0" marL="0">
+              <a:buNone/>
+            </a:pPr>
+            <a:r>
+              <a:rPr lang="en-US" sz="1250" dirty="0">
+                <a:solidFill>
+                  <a:srgbClr val="6B7683"/>
+                </a:solidFill>
+                <a:latin typeface="Calibri" pitchFamily="34" charset="0"/>
+                <a:ea typeface="Calibri" pitchFamily="34" charset="-122"/>
+                <a:cs typeface="Calibri" pitchFamily="34" charset="-120"/>
+              </a:rPr>
+              <a:t>Appropriateness</a:t>
+            </a:r>
+            <a:endParaRPr lang="en-US" sz="1250" dirty="0"/>
+          </a:p>
+        </p:txBody>
+      </p:sp>
+      <p:sp>
+        <p:nvSpPr>
+          <p:cNvPr id="21" name="Text 19"/>
+          <p:cNvSpPr/>
+          <p:nvPr/>
+        </p:nvSpPr>
+        <p:spPr>
+          <a:xfrm>
+            <a:off x="6446520" y="4160520"/>
+            <a:ext cx="4800600" cy="457200"/>
+          </a:xfrm>
+          <a:prstGeom prst="rect">
+            <a:avLst/>
+          </a:prstGeom>
+          <a:noFill/>
+          <a:ln/>
+        </p:spPr>
+        <p:txBody>
+          <a:bodyPr wrap="square" lIns="0" tIns="0" rIns="0" bIns="0" rtlCol="0" anchor="ctr"/>
+          <a:lstStyle/>
+          <a:p>
+            <a:pPr indent="0" marL="0">
+              <a:lnSpc>
+                <a:spcPts val="1700"/>
+              </a:lnSpc>
+              <a:buNone/>
+            </a:pPr>
+            <a:r>
+              <a:rPr lang="en-US" sz="1300" i="1" dirty="0">
+                <a:solidFill>
+                  <a:srgbClr val="FF5A3C"/>
+                </a:solidFill>
+                <a:latin typeface="Calibri" pitchFamily="34" charset="0"/>
+                <a:ea typeface="Calibri" pitchFamily="34" charset="-122"/>
+                <a:cs typeface="Calibri" pitchFamily="34" charset="-120"/>
+              </a:rPr>
+              <a:t>Seltener grün — aber echte, robuste, benutzerorientierte Tests.</a:t>
+            </a:r>
+            <a:endParaRPr lang="en-US" sz="1300" dirty="0"/>
+          </a:p>
+        </p:txBody>
+      </p:sp>
+      <p:sp>
+        <p:nvSpPr>
+          <p:cNvPr id="22" name="Shape 20"/>
+          <p:cNvSpPr/>
+          <p:nvPr/>
+        </p:nvSpPr>
+        <p:spPr>
+          <a:xfrm>
+            <a:off x="640080" y="5029200"/>
+            <a:ext cx="10881360" cy="1051560"/>
+          </a:xfrm>
+          <a:prstGeom prst="roundRect">
+            <a:avLst>
+              <a:gd name="adj" fmla="val 8696"/>
+            </a:avLst>
+          </a:prstGeom>
+          <a:solidFill>
+            <a:srgbClr val="17202B"/>
+          </a:solidFill>
+          <a:ln/>
+        </p:spPr>
+      </p:sp>
+      <p:sp>
+        <p:nvSpPr>
+          <p:cNvPr id="23" name="Text 21"/>
+          <p:cNvSpPr/>
+          <p:nvPr/>
+        </p:nvSpPr>
+        <p:spPr>
+          <a:xfrm>
+            <a:off x="914400" y="5193792"/>
+            <a:ext cx="10332720" cy="731520"/>
+          </a:xfrm>
+          <a:prstGeom prst="rect">
+            <a:avLst/>
+          </a:prstGeom>
+          <a:noFill/>
+          <a:ln/>
+        </p:spPr>
+        <p:txBody>
+          <a:bodyPr wrap="square" rtlCol="0" anchor="ctr"/>
+          <a:lstStyle/>
+          <a:p>
+            <a:pPr indent="0" marL="0">
+              <a:lnSpc>
+                <a:spcPts val="2000"/>
+              </a:lnSpc>
+              <a:buNone/>
+            </a:pPr>
+            <a:r>
+              <a:rPr lang="en-US" sz="1450" b="1" dirty="0">
+                <a:solidFill>
+                  <a:srgbClr val="FF5A3C"/>
+                </a:solidFill>
+                <a:latin typeface="Calibri" pitchFamily="34" charset="0"/>
+                <a:ea typeface="Calibri" pitchFamily="34" charset="-122"/>
+                <a:cs typeface="Calibri" pitchFamily="34" charset="-120"/>
+              </a:rPr>
+              <a:t>Kernpunkt:  </a:t>
+            </a:r>
+            <a:pPr indent="0" marL="0">
+              <a:lnSpc>
+                <a:spcPts val="2000"/>
+              </a:lnSpc>
+              <a:buNone/>
+            </a:pPr>
+            <a:r>
+              <a:rPr lang="en-US" sz="1450" dirty="0">
+                <a:solidFill>
+                  <a:srgbClr val="FFFFFF"/>
+                </a:solidFill>
+                <a:latin typeface="Calibri" pitchFamily="34" charset="0"/>
+                <a:ea typeface="Calibri" pitchFamily="34" charset="-122"/>
+                <a:cs typeface="Calibri" pitchFamily="34" charset="-120"/>
+              </a:rPr>
+              <a:t>Die Pass-Rate allein täuscht. Der Crawler besteht, weil er kaum etwas prüft; der LLM-Agent riskiert Fehlschläge, weil er echtes Verhalten verifiziert. Erst die ISO-Bewertung macht diesen Unterschied sichtbar.</a:t>
+            </a:r>
+            <a:endParaRPr lang="en-US" sz="1450" dirty="0"/>
+          </a:p>
+        </p:txBody>
+      </p:sp>
+      <p:sp>
+        <p:nvSpPr>
+          <p:cNvPr id="24" name="Text 22"/>
+          <p:cNvSpPr/>
+          <p:nvPr/>
+        </p:nvSpPr>
+        <p:spPr>
+          <a:xfrm>
+            <a:off x="640080" y="6199632"/>
+            <a:ext cx="5486400" cy="274320"/>
+          </a:xfrm>
+          <a:prstGeom prst="rect">
+            <a:avLst/>
+          </a:prstGeom>
+          <a:noFill/>
+          <a:ln/>
+        </p:spPr>
+        <p:txBody>
+          <a:bodyPr wrap="square" rtlCol="0" anchor="ctr"/>
+          <a:lstStyle/>
+          <a:p>
+            <a:pPr indent="0" marL="0">
+              <a:buNone/>
+            </a:pPr>
+            <a:r>
+              <a:rPr lang="en-US" sz="1100" i="1" dirty="0">
+                <a:solidFill>
+                  <a:srgbClr val="6B7683"/>
+                </a:solidFill>
+                <a:latin typeface="Calibri" pitchFamily="34" charset="0"/>
+                <a:ea typeface="Calibri" pitchFamily="34" charset="-122"/>
+                <a:cs typeface="Calibri" pitchFamily="34" charset="-120"/>
+              </a:rPr>
+              <a:t>Zahlen: Juice Shop, 50 Wiederholungen.</a:t>
+            </a:r>
+            <a:endParaRPr lang="en-US" sz="1100" dirty="0"/>
+          </a:p>
+        </p:txBody>
+      </p:sp>
+    </p:spTree>
+  </p:cSld>
+  <p:clrMapOvr>
+    <a:masterClrMapping/>
+  </p:clrMapOvr>
+</p:sld>
+</file>
+
+<file path=ppt/slides/slide14.xml><?xml version="1.0" encoding="utf-8"?>
+<p:sld xmlns:a="http://schemas.openxmlformats.org/drawingml/2006/main" xmlns:r="http://schemas.openxmlformats.org/officeDocument/2006/relationships" xmlns:p="http://schemas.openxmlformats.org/presentationml/2006/main">
+  <p:cSld name="Slide 14">
     <p:bg>
       <p:bgPr>
         <a:solidFill>
@@ -5480,7 +6477,7 @@
                 <a:ea typeface="Cambria" pitchFamily="34" charset="-122"/>
                 <a:cs typeface="Cambria" pitchFamily="34" charset="-120"/>
               </a:rPr>
-              <a:t>LLM-Agent schlägt Crawler</a:t>
+              <a:t>Live schlägt statisch</a:t>
             </a:r>
             <a:endParaRPr lang="en-US" sz="2300" dirty="0"/>
           </a:p>
@@ -5522,7 +6519,7 @@
                 <a:ea typeface="Calibri" pitchFamily="34" charset="-122"/>
                 <a:cs typeface="Calibri" pitchFamily="34" charset="-120"/>
               </a:rPr>
-              <a:t>Der reine LLM-Agent übertrifft den klassischen Crawler deutlich — 0.71 vs. 0.60 ISO Functional Suitability.</a:t>
+              <a:t>Beide Methoden-Duelle gehen an die live erkundenden Agenten: L &gt; C (Methode 1), S &gt; H (Methode 2).</a:t>
             </a:r>
             <a:endParaRPr lang="en-US" sz="1450" dirty="0"/>
           </a:p>
@@ -5577,7 +6574,7 @@
             <a:r>
               <a:rPr lang="en-US" sz="4000" b="1" dirty="0">
                 <a:solidFill>
-                  <a:srgbClr val="1FA88F"/>
+                  <a:srgbClr val="E0912F"/>
                 </a:solidFill>
                 <a:latin typeface="Cambria" pitchFamily="34" charset="0"/>
                 <a:ea typeface="Cambria" pitchFamily="34" charset="-122"/>
@@ -5622,7 +6619,7 @@
                 <a:ea typeface="Cambria" pitchFamily="34" charset="-122"/>
                 <a:cs typeface="Cambria" pitchFamily="34" charset="-120"/>
               </a:rPr>
-              <a:t>Hybrid gewinnt nicht</a:t>
+              <a:t>„Grün“ ist nicht „gut“</a:t>
             </a:r>
             <a:endParaRPr lang="en-US" sz="2300" dirty="0"/>
           </a:p>
@@ -5664,7 +6661,7 @@
                 <a:ea typeface="Calibri" pitchFamily="34" charset="-122"/>
                 <a:cs typeface="Calibri" pitchFamily="34" charset="-120"/>
               </a:rPr>
-              <a:t>Crawler-Erdung + Story hebt die Suite nicht über den reinen Agenten. Die Hypothese wird nicht bestätigt.</a:t>
+              <a:t>Der Crawler ist zu 100 % grün — über leere Smoke-Prüfungen. Pass-Rate und Assertion-Stärke immer zusammen lesen.</a:t>
             </a:r>
             <a:endParaRPr lang="en-US" sz="1450" dirty="0"/>
           </a:p>
@@ -5719,7 +6716,7 @@
             <a:r>
               <a:rPr lang="en-US" sz="4000" b="1" dirty="0">
                 <a:solidFill>
-                  <a:srgbClr val="E0912F"/>
+                  <a:srgbClr val="1FA88F"/>
                 </a:solidFill>
                 <a:latin typeface="Cambria" pitchFamily="34" charset="0"/>
                 <a:ea typeface="Cambria" pitchFamily="34" charset="-122"/>
@@ -5764,7 +6761,7 @@
                 <a:ea typeface="Cambria" pitchFamily="34" charset="-122"/>
                 <a:cs typeface="Cambria" pitchFamily="34" charset="-120"/>
               </a:rPr>
-              <a:t>Qualität vs. Zuverlässigkeit</a:t>
+              <a:t>Grounding braucht Enforcement</a:t>
             </a:r>
             <a:endParaRPr lang="en-US" sz="2300" dirty="0"/>
           </a:p>
@@ -5806,7 +6803,7 @@
                 <a:ea typeface="Calibri" pitchFamily="34" charset="-122"/>
                 <a:cs typeface="Calibri" pitchFamily="34" charset="-120"/>
               </a:rPr>
-              <a:t>Der Crawler ist zuverlässig-aber-flach, der LLM-Agent aussagekräftig-aber-flakiger. Ein echter Trade-off.</a:t>
+              <a:t>Die Crawler-Karte hilft nur, wenn sie die Locator-Wahl hart erzwingt. Als bloßer Kontext ignoriert das Modell sie.</a:t>
             </a:r>
             <a:endParaRPr lang="en-US" sz="1450" dirty="0"/>
           </a:p>
@@ -5820,9 +6817,9 @@
 </p:sld>
 </file>
 
-<file path=ppt/slides/slide14.xml><?xml version="1.0" encoding="utf-8"?>
+<file path=ppt/slides/slide15.xml><?xml version="1.0" encoding="utf-8"?>
 <p:sld xmlns:a="http://schemas.openxmlformats.org/drawingml/2006/main" xmlns:r="http://schemas.openxmlformats.org/officeDocument/2006/relationships" xmlns:p="http://schemas.openxmlformats.org/presentationml/2006/main">
-  <p:cSld name="Slide 14">
+  <p:cSld name="Slide 15">
     <p:bg>
       <p:bgPr>
         <a:solidFill>
@@ -6418,396 +7415,6 @@
               <a:t>Wir berichten Mittelwerte ± Standardabweichung — und nennen den robusten Kern (L ≥ C) getrennt von unentschiedenen Details.</a:t>
             </a:r>
             <a:endParaRPr lang="en-US" sz="1350" dirty="0"/>
-          </a:p>
-        </p:txBody>
-      </p:sp>
-    </p:spTree>
-  </p:cSld>
-  <p:clrMapOvr>
-    <a:masterClrMapping/>
-  </p:clrMapOvr>
-</p:sld>
-</file>
-
-<file path=ppt/slides/slide15.xml><?xml version="1.0" encoding="utf-8"?>
-<p:sld xmlns:a="http://schemas.openxmlformats.org/drawingml/2006/main" xmlns:r="http://schemas.openxmlformats.org/officeDocument/2006/relationships" xmlns:p="http://schemas.openxmlformats.org/presentationml/2006/main">
-  <p:cSld name="Slide 15">
-    <p:bg>
-      <p:bgPr>
-        <a:solidFill>
-          <a:srgbClr val="17202B"/>
-        </a:solidFill>
-      </p:bgPr>
-    </p:bg>
-    <p:spTree>
-      <p:nvGrpSpPr>
-        <p:cNvPr id="1" name=""/>
-        <p:cNvGrpSpPr/>
-        <p:nvPr/>
-      </p:nvGrpSpPr>
-      <p:grpSpPr>
-        <a:xfrm>
-          <a:off x="0" y="0"/>
-          <a:ext cx="0" cy="0"/>
-          <a:chOff x="0" y="0"/>
-          <a:chExt cx="0" cy="0"/>
-        </a:xfrm>
-      </p:grpSpPr>
-      <p:sp>
-        <p:nvSpPr>
-          <p:cNvPr id="2" name="Text 0"/>
-          <p:cNvSpPr/>
-          <p:nvPr/>
-        </p:nvSpPr>
-        <p:spPr>
-          <a:xfrm>
-            <a:off x="640080" y="640080"/>
-            <a:ext cx="7315200" cy="274320"/>
-          </a:xfrm>
-          <a:prstGeom prst="rect">
-            <a:avLst/>
-          </a:prstGeom>
-          <a:noFill/>
-          <a:ln/>
-        </p:spPr>
-        <p:txBody>
-          <a:bodyPr wrap="square" lIns="0" tIns="0" rIns="0" bIns="0" rtlCol="0" anchor="ctr"/>
-          <a:lstStyle/>
-          <a:p>
-            <a:pPr indent="0" marL="0">
-              <a:buNone/>
-            </a:pPr>
-            <a:r>
-              <a:rPr lang="en-US" sz="1100" b="1" spc="200" kern="0" dirty="0">
-                <a:solidFill>
-                  <a:srgbClr val="FF5A3C"/>
-                </a:solidFill>
-                <a:latin typeface="Courier New" pitchFamily="34" charset="0"/>
-                <a:ea typeface="Courier New" pitchFamily="34" charset="-122"/>
-                <a:cs typeface="Courier New" pitchFamily="34" charset="-120"/>
-              </a:rPr>
-              <a:t>BEDEUTUNG</a:t>
-            </a:r>
-            <a:endParaRPr lang="en-US" sz="1100" dirty="0"/>
-          </a:p>
-        </p:txBody>
-      </p:sp>
-      <p:sp>
-        <p:nvSpPr>
-          <p:cNvPr id="3" name="Text 1"/>
-          <p:cNvSpPr/>
-          <p:nvPr/>
-        </p:nvSpPr>
-        <p:spPr>
-          <a:xfrm>
-            <a:off x="603504" y="1188720"/>
-            <a:ext cx="10972800" cy="1645920"/>
-          </a:xfrm>
-          <a:prstGeom prst="rect">
-            <a:avLst/>
-          </a:prstGeom>
-          <a:noFill/>
-          <a:ln/>
-        </p:spPr>
-        <p:txBody>
-          <a:bodyPr wrap="square" rtlCol="0" anchor="ctr"/>
-          <a:lstStyle/>
-          <a:p>
-            <a:pPr indent="0" marL="0">
-              <a:lnSpc>
-                <a:spcPts val="4200"/>
-              </a:lnSpc>
-              <a:buNone/>
-            </a:pPr>
-            <a:r>
-              <a:rPr lang="en-US" sz="3400" b="1" dirty="0">
-                <a:solidFill>
-                  <a:srgbClr val="FFFFFF"/>
-                </a:solidFill>
-                <a:latin typeface="Cambria" pitchFamily="34" charset="0"/>
-                <a:ea typeface="Cambria" pitchFamily="34" charset="-122"/>
-                <a:cs typeface="Cambria" pitchFamily="34" charset="-120"/>
-              </a:rPr>
-              <a:t>LLM-Agenten sind eine ernstzunehmende, </a:t>
-            </a:r>
-            <a:pPr indent="0" marL="0">
-              <a:lnSpc>
-                <a:spcPts val="4200"/>
-              </a:lnSpc>
-              <a:buNone/>
-            </a:pPr>
-            <a:r>
-              <a:rPr lang="en-US" sz="3400" b="1" dirty="0">
-                <a:solidFill>
-                  <a:srgbClr val="FF5A3C"/>
-                </a:solidFill>
-                <a:latin typeface="Cambria" pitchFamily="34" charset="0"/>
-                <a:ea typeface="Cambria" pitchFamily="34" charset="-122"/>
-                <a:cs typeface="Cambria" pitchFamily="34" charset="-120"/>
-              </a:rPr>
-              <a:t>qualitativ höherwertige</a:t>
-            </a:r>
-            <a:pPr indent="0" marL="0">
-              <a:lnSpc>
-                <a:spcPts val="4200"/>
-              </a:lnSpc>
-              <a:buNone/>
-            </a:pPr>
-            <a:r>
-              <a:rPr lang="en-US" sz="3400" b="1" dirty="0">
-                <a:solidFill>
-                  <a:srgbClr val="FFFFFF"/>
-                </a:solidFill>
-                <a:latin typeface="Cambria" pitchFamily="34" charset="0"/>
-                <a:ea typeface="Cambria" pitchFamily="34" charset="-122"/>
-                <a:cs typeface="Cambria" pitchFamily="34" charset="-120"/>
-              </a:rPr>
-              <a:t> Alternative zum klassischen Crawler.</a:t>
-            </a:r>
-            <a:endParaRPr lang="en-US" sz="3400" dirty="0"/>
-          </a:p>
-        </p:txBody>
-      </p:sp>
-      <p:sp>
-        <p:nvSpPr>
-          <p:cNvPr id="4" name="Text 2"/>
-          <p:cNvSpPr/>
-          <p:nvPr/>
-        </p:nvSpPr>
-        <p:spPr>
-          <a:xfrm>
-            <a:off x="640080" y="3154680"/>
-            <a:ext cx="3108960" cy="822960"/>
-          </a:xfrm>
-          <a:prstGeom prst="rect">
-            <a:avLst/>
-          </a:prstGeom>
-          <a:noFill/>
-          <a:ln/>
-        </p:spPr>
-        <p:txBody>
-          <a:bodyPr wrap="square" lIns="0" tIns="0" rIns="0" bIns="0" rtlCol="0" anchor="t"/>
-          <a:lstStyle/>
-          <a:p>
-            <a:pPr indent="0" marL="0">
-              <a:buNone/>
-            </a:pPr>
-            <a:r>
-              <a:rPr lang="en-US" sz="1300" b="1" dirty="0">
-                <a:solidFill>
-                  <a:srgbClr val="1FA88F"/>
-                </a:solidFill>
-                <a:latin typeface="Courier New" pitchFamily="34" charset="0"/>
-                <a:ea typeface="Courier New" pitchFamily="34" charset="-122"/>
-                <a:cs typeface="Courier New" pitchFamily="34" charset="-120"/>
-              </a:rPr>
-              <a:t>Für die Praxis</a:t>
-            </a:r>
-            <a:endParaRPr lang="en-US" sz="1300" dirty="0"/>
-          </a:p>
-        </p:txBody>
-      </p:sp>
-      <p:sp>
-        <p:nvSpPr>
-          <p:cNvPr id="5" name="Text 3"/>
-          <p:cNvSpPr/>
-          <p:nvPr/>
-        </p:nvSpPr>
-        <p:spPr>
-          <a:xfrm>
-            <a:off x="3840480" y="3136392"/>
-            <a:ext cx="7680960" cy="822960"/>
-          </a:xfrm>
-          <a:prstGeom prst="rect">
-            <a:avLst/>
-          </a:prstGeom>
-          <a:noFill/>
-          <a:ln/>
-        </p:spPr>
-        <p:txBody>
-          <a:bodyPr wrap="square" lIns="0" tIns="0" rIns="0" bIns="0" rtlCol="0" anchor="ctr"/>
-          <a:lstStyle/>
-          <a:p>
-            <a:pPr indent="0" marL="0">
-              <a:lnSpc>
-                <a:spcPts val="2100"/>
-              </a:lnSpc>
-              <a:buNone/>
-            </a:pPr>
-            <a:r>
-              <a:rPr lang="en-US" sz="1550" dirty="0">
-                <a:solidFill>
-                  <a:srgbClr val="9AA7B4"/>
-                </a:solidFill>
-                <a:latin typeface="Calibri" pitchFamily="34" charset="0"/>
-                <a:ea typeface="Calibri" pitchFamily="34" charset="-122"/>
-                <a:cs typeface="Calibri" pitchFamily="34" charset="-120"/>
-              </a:rPr>
-              <a:t>Wer aussagekräftige UI-Tests will, fährt mit dem LLM-Agenten besser — auch bei etwas mehr Flakiness.</a:t>
-            </a:r>
-            <a:endParaRPr lang="en-US" sz="1550" dirty="0"/>
-          </a:p>
-        </p:txBody>
-      </p:sp>
-      <p:sp>
-        <p:nvSpPr>
-          <p:cNvPr id="6" name="Text 4"/>
-          <p:cNvSpPr/>
-          <p:nvPr/>
-        </p:nvSpPr>
-        <p:spPr>
-          <a:xfrm>
-            <a:off x="640080" y="4142232"/>
-            <a:ext cx="3108960" cy="822960"/>
-          </a:xfrm>
-          <a:prstGeom prst="rect">
-            <a:avLst/>
-          </a:prstGeom>
-          <a:noFill/>
-          <a:ln/>
-        </p:spPr>
-        <p:txBody>
-          <a:bodyPr wrap="square" lIns="0" tIns="0" rIns="0" bIns="0" rtlCol="0" anchor="t"/>
-          <a:lstStyle/>
-          <a:p>
-            <a:pPr indent="0" marL="0">
-              <a:buNone/>
-            </a:pPr>
-            <a:r>
-              <a:rPr lang="en-US" sz="1300" b="1" dirty="0">
-                <a:solidFill>
-                  <a:srgbClr val="1FA88F"/>
-                </a:solidFill>
-                <a:latin typeface="Courier New" pitchFamily="34" charset="0"/>
-                <a:ea typeface="Courier New" pitchFamily="34" charset="-122"/>
-                <a:cs typeface="Courier New" pitchFamily="34" charset="-120"/>
-              </a:rPr>
-              <a:t>Für die Methode</a:t>
-            </a:r>
-            <a:endParaRPr lang="en-US" sz="1300" dirty="0"/>
-          </a:p>
-        </p:txBody>
-      </p:sp>
-      <p:sp>
-        <p:nvSpPr>
-          <p:cNvPr id="7" name="Text 5"/>
-          <p:cNvSpPr/>
-          <p:nvPr/>
-        </p:nvSpPr>
-        <p:spPr>
-          <a:xfrm>
-            <a:off x="3840480" y="4123944"/>
-            <a:ext cx="7680960" cy="822960"/>
-          </a:xfrm>
-          <a:prstGeom prst="rect">
-            <a:avLst/>
-          </a:prstGeom>
-          <a:noFill/>
-          <a:ln/>
-        </p:spPr>
-        <p:txBody>
-          <a:bodyPr wrap="square" lIns="0" tIns="0" rIns="0" bIns="0" rtlCol="0" anchor="ctr"/>
-          <a:lstStyle/>
-          <a:p>
-            <a:pPr indent="0" marL="0">
-              <a:lnSpc>
-                <a:spcPts val="2100"/>
-              </a:lnSpc>
-              <a:buNone/>
-            </a:pPr>
-            <a:r>
-              <a:rPr lang="en-US" sz="1550" dirty="0">
-                <a:solidFill>
-                  <a:srgbClr val="9AA7B4"/>
-                </a:solidFill>
-                <a:latin typeface="Calibri" pitchFamily="34" charset="0"/>
-                <a:ea typeface="Calibri" pitchFamily="34" charset="-122"/>
-                <a:cs typeface="Calibri" pitchFamily="34" charset="-120"/>
-              </a:rPr>
-              <a:t>Erdung über eine Crawler-Karte war hier kein Hebel. Der Agent explorierte selbst gut genug.</a:t>
-            </a:r>
-            <a:endParaRPr lang="en-US" sz="1550" dirty="0"/>
-          </a:p>
-        </p:txBody>
-      </p:sp>
-      <p:sp>
-        <p:nvSpPr>
-          <p:cNvPr id="8" name="Text 6"/>
-          <p:cNvSpPr/>
-          <p:nvPr/>
-        </p:nvSpPr>
-        <p:spPr>
-          <a:xfrm>
-            <a:off x="640080" y="5129784"/>
-            <a:ext cx="3108960" cy="822960"/>
-          </a:xfrm>
-          <a:prstGeom prst="rect">
-            <a:avLst/>
-          </a:prstGeom>
-          <a:noFill/>
-          <a:ln/>
-        </p:spPr>
-        <p:txBody>
-          <a:bodyPr wrap="square" lIns="0" tIns="0" rIns="0" bIns="0" rtlCol="0" anchor="t"/>
-          <a:lstStyle/>
-          <a:p>
-            <a:pPr indent="0" marL="0">
-              <a:buNone/>
-            </a:pPr>
-            <a:r>
-              <a:rPr lang="en-US" sz="1300" b="1" dirty="0">
-                <a:solidFill>
-                  <a:srgbClr val="1FA88F"/>
-                </a:solidFill>
-                <a:latin typeface="Courier New" pitchFamily="34" charset="0"/>
-                <a:ea typeface="Courier New" pitchFamily="34" charset="-122"/>
-                <a:cs typeface="Courier New" pitchFamily="34" charset="-120"/>
-              </a:rPr>
-              <a:t>Für die Messung</a:t>
-            </a:r>
-            <a:endParaRPr lang="en-US" sz="1300" dirty="0"/>
-          </a:p>
-        </p:txBody>
-      </p:sp>
-      <p:sp>
-        <p:nvSpPr>
-          <p:cNvPr id="9" name="Text 7"/>
-          <p:cNvSpPr/>
-          <p:nvPr/>
-        </p:nvSpPr>
-        <p:spPr>
-          <a:xfrm>
-            <a:off x="3840480" y="5111496"/>
-            <a:ext cx="7680960" cy="822960"/>
-          </a:xfrm>
-          <a:prstGeom prst="rect">
-            <a:avLst/>
-          </a:prstGeom>
-          <a:noFill/>
-          <a:ln/>
-        </p:spPr>
-        <p:txBody>
-          <a:bodyPr wrap="square" lIns="0" tIns="0" rIns="0" bIns="0" rtlCol="0" anchor="ctr"/>
-          <a:lstStyle/>
-          <a:p>
-            <a:pPr indent="0" marL="0">
-              <a:lnSpc>
-                <a:spcPts val="2100"/>
-              </a:lnSpc>
-              <a:buNone/>
-            </a:pPr>
-            <a:r>
-              <a:rPr lang="en-US" sz="1550" dirty="0">
-                <a:solidFill>
-                  <a:srgbClr val="9AA7B4"/>
-                </a:solidFill>
-                <a:latin typeface="Calibri" pitchFamily="34" charset="0"/>
-                <a:ea typeface="Calibri" pitchFamily="34" charset="-122"/>
-                <a:cs typeface="Calibri" pitchFamily="34" charset="-120"/>
-              </a:rPr>
-              <a:t>Pass-Rate allein ist irreführend. Erst eine mehrdimensionale, ISO-basierte Bewertung zeigt die Wahrheit.</a:t>
-            </a:r>
-            <a:endParaRPr lang="en-US" sz="1550" dirty="0"/>
           </a:p>
         </p:txBody>
       </p:sp>
@@ -6851,8 +7458,47 @@
         </p:nvSpPr>
         <p:spPr>
           <a:xfrm>
-            <a:off x="603504" y="2286000"/>
-            <a:ext cx="8229600" cy="1097280"/>
+            <a:off x="640080" y="640080"/>
+            <a:ext cx="7315200" cy="274320"/>
+          </a:xfrm>
+          <a:prstGeom prst="rect">
+            <a:avLst/>
+          </a:prstGeom>
+          <a:noFill/>
+          <a:ln/>
+        </p:spPr>
+        <p:txBody>
+          <a:bodyPr wrap="square" lIns="0" tIns="0" rIns="0" bIns="0" rtlCol="0" anchor="ctr"/>
+          <a:lstStyle/>
+          <a:p>
+            <a:pPr indent="0" marL="0">
+              <a:buNone/>
+            </a:pPr>
+            <a:r>
+              <a:rPr lang="en-US" sz="1100" b="1" spc="200" kern="0" dirty="0">
+                <a:solidFill>
+                  <a:srgbClr val="FF5A3C"/>
+                </a:solidFill>
+                <a:latin typeface="Courier New" pitchFamily="34" charset="0"/>
+                <a:ea typeface="Courier New" pitchFamily="34" charset="-122"/>
+                <a:cs typeface="Courier New" pitchFamily="34" charset="-120"/>
+              </a:rPr>
+              <a:t>BEDEUTUNG</a:t>
+            </a:r>
+            <a:endParaRPr lang="en-US" sz="1100" dirty="0"/>
+          </a:p>
+        </p:txBody>
+      </p:sp>
+      <p:sp>
+        <p:nvSpPr>
+          <p:cNvPr id="3" name="Text 1"/>
+          <p:cNvSpPr/>
+          <p:nvPr/>
+        </p:nvSpPr>
+        <p:spPr>
+          <a:xfrm>
+            <a:off x="603504" y="1188720"/>
+            <a:ext cx="10972800" cy="1645920"/>
           </a:xfrm>
           <a:prstGeom prst="rect">
             <a:avLst/>
@@ -6865,10 +7511,13 @@
           <a:lstStyle/>
           <a:p>
             <a:pPr indent="0" marL="0">
-              <a:buNone/>
-            </a:pPr>
-            <a:r>
-              <a:rPr lang="en-US" sz="6600" b="1" dirty="0">
+              <a:lnSpc>
+                <a:spcPts val="4200"/>
+              </a:lnSpc>
+              <a:buNone/>
+            </a:pPr>
+            <a:r>
+              <a:rPr lang="en-US" sz="3400" b="1" dirty="0">
                 <a:solidFill>
                   <a:srgbClr val="FFFFFF"/>
                 </a:solidFill>
@@ -6876,85 +7525,433 @@
                 <a:ea typeface="Cambria" pitchFamily="34" charset="-122"/>
                 <a:cs typeface="Cambria" pitchFamily="34" charset="-120"/>
               </a:rPr>
-              <a:t>Danke.</a:t>
-            </a:r>
-            <a:endParaRPr lang="en-US" sz="6600" dirty="0"/>
-          </a:p>
-        </p:txBody>
-      </p:sp>
-      <p:sp>
-        <p:nvSpPr>
-          <p:cNvPr id="3" name="Text 1"/>
-          <p:cNvSpPr/>
-          <p:nvPr/>
-        </p:nvSpPr>
-        <p:spPr>
-          <a:xfrm>
-            <a:off x="640080" y="3566160"/>
-            <a:ext cx="8229600" cy="548640"/>
-          </a:xfrm>
-          <a:prstGeom prst="rect">
-            <a:avLst/>
-          </a:prstGeom>
-          <a:noFill/>
-          <a:ln/>
-        </p:spPr>
-        <p:txBody>
-          <a:bodyPr wrap="square" rtlCol="0" anchor="ctr"/>
-          <a:lstStyle/>
-          <a:p>
-            <a:pPr indent="0" marL="0">
-              <a:buNone/>
-            </a:pPr>
-            <a:r>
-              <a:rPr lang="en-US" sz="2200" dirty="0">
+              <a:t>LLM-Agenten sind eine ernstzunehmende, </a:t>
+            </a:r>
+            <a:pPr indent="0" marL="0">
+              <a:lnSpc>
+                <a:spcPts val="4200"/>
+              </a:lnSpc>
+              <a:buNone/>
+            </a:pPr>
+            <a:r>
+              <a:rPr lang="en-US" sz="3400" b="1" dirty="0">
                 <a:solidFill>
                   <a:srgbClr val="FF5A3C"/>
+                </a:solidFill>
+                <a:latin typeface="Cambria" pitchFamily="34" charset="0"/>
+                <a:ea typeface="Cambria" pitchFamily="34" charset="-122"/>
+                <a:cs typeface="Cambria" pitchFamily="34" charset="-120"/>
+              </a:rPr>
+              <a:t>qualitativ höherwertige</a:t>
+            </a:r>
+            <a:pPr indent="0" marL="0">
+              <a:lnSpc>
+                <a:spcPts val="4200"/>
+              </a:lnSpc>
+              <a:buNone/>
+            </a:pPr>
+            <a:r>
+              <a:rPr lang="en-US" sz="3400" b="1" dirty="0">
+                <a:solidFill>
+                  <a:srgbClr val="FFFFFF"/>
+                </a:solidFill>
+                <a:latin typeface="Cambria" pitchFamily="34" charset="0"/>
+                <a:ea typeface="Cambria" pitchFamily="34" charset="-122"/>
+                <a:cs typeface="Cambria" pitchFamily="34" charset="-120"/>
+              </a:rPr>
+              <a:t> Alternative zum klassischen Crawler.</a:t>
+            </a:r>
+            <a:endParaRPr lang="en-US" sz="3400" dirty="0"/>
+          </a:p>
+        </p:txBody>
+      </p:sp>
+      <p:sp>
+        <p:nvSpPr>
+          <p:cNvPr id="4" name="Text 2"/>
+          <p:cNvSpPr/>
+          <p:nvPr/>
+        </p:nvSpPr>
+        <p:spPr>
+          <a:xfrm>
+            <a:off x="640080" y="3154680"/>
+            <a:ext cx="3108960" cy="822960"/>
+          </a:xfrm>
+          <a:prstGeom prst="rect">
+            <a:avLst/>
+          </a:prstGeom>
+          <a:noFill/>
+          <a:ln/>
+        </p:spPr>
+        <p:txBody>
+          <a:bodyPr wrap="square" lIns="0" tIns="0" rIns="0" bIns="0" rtlCol="0" anchor="t"/>
+          <a:lstStyle/>
+          <a:p>
+            <a:pPr indent="0" marL="0">
+              <a:buNone/>
+            </a:pPr>
+            <a:r>
+              <a:rPr lang="en-US" sz="1300" b="1" dirty="0">
+                <a:solidFill>
+                  <a:srgbClr val="1FA88F"/>
+                </a:solidFill>
+                <a:latin typeface="Courier New" pitchFamily="34" charset="0"/>
+                <a:ea typeface="Courier New" pitchFamily="34" charset="-122"/>
+                <a:cs typeface="Courier New" pitchFamily="34" charset="-120"/>
+              </a:rPr>
+              <a:t>Für die Praxis</a:t>
+            </a:r>
+            <a:endParaRPr lang="en-US" sz="1300" dirty="0"/>
+          </a:p>
+        </p:txBody>
+      </p:sp>
+      <p:sp>
+        <p:nvSpPr>
+          <p:cNvPr id="5" name="Text 3"/>
+          <p:cNvSpPr/>
+          <p:nvPr/>
+        </p:nvSpPr>
+        <p:spPr>
+          <a:xfrm>
+            <a:off x="3840480" y="3136392"/>
+            <a:ext cx="7680960" cy="822960"/>
+          </a:xfrm>
+          <a:prstGeom prst="rect">
+            <a:avLst/>
+          </a:prstGeom>
+          <a:noFill/>
+          <a:ln/>
+        </p:spPr>
+        <p:txBody>
+          <a:bodyPr wrap="square" lIns="0" tIns="0" rIns="0" bIns="0" rtlCol="0" anchor="ctr"/>
+          <a:lstStyle/>
+          <a:p>
+            <a:pPr indent="0" marL="0">
+              <a:lnSpc>
+                <a:spcPts val="2100"/>
+              </a:lnSpc>
+              <a:buNone/>
+            </a:pPr>
+            <a:r>
+              <a:rPr lang="en-US" sz="1550" dirty="0">
+                <a:solidFill>
+                  <a:srgbClr val="9AA7B4"/>
                 </a:solidFill>
                 <a:latin typeface="Calibri" pitchFamily="34" charset="0"/>
                 <a:ea typeface="Calibri" pitchFamily="34" charset="-122"/>
                 <a:cs typeface="Calibri" pitchFamily="34" charset="-120"/>
               </a:rPr>
-              <a:t>Fragen &amp; Diskussion</a:t>
-            </a:r>
-            <a:endParaRPr lang="en-US" sz="2200" dirty="0"/>
-          </a:p>
-        </p:txBody>
-      </p:sp>
-      <p:sp>
-        <p:nvSpPr>
-          <p:cNvPr id="4" name="Text 2"/>
-          <p:cNvSpPr/>
-          <p:nvPr/>
-        </p:nvSpPr>
-        <p:spPr>
-          <a:xfrm>
-            <a:off x="640080" y="6035040"/>
-            <a:ext cx="10972800" cy="365760"/>
-          </a:xfrm>
-          <a:prstGeom prst="rect">
-            <a:avLst/>
-          </a:prstGeom>
-          <a:noFill/>
-          <a:ln/>
-        </p:spPr>
-        <p:txBody>
-          <a:bodyPr wrap="square" rtlCol="0" anchor="ctr"/>
-          <a:lstStyle/>
-          <a:p>
-            <a:pPr indent="0" marL="0">
-              <a:buNone/>
-            </a:pPr>
-            <a:r>
-              <a:rPr lang="en-US" sz="1200" spc="100" kern="0" dirty="0">
-                <a:solidFill>
-                  <a:srgbClr val="9AA7B4"/>
+              <a:t>Wer aussagekräftige UI-Tests will, fährt mit dem LLM-Agenten besser — auch bei etwas mehr Flakiness.</a:t>
+            </a:r>
+            <a:endParaRPr lang="en-US" sz="1550" dirty="0"/>
+          </a:p>
+        </p:txBody>
+      </p:sp>
+      <p:sp>
+        <p:nvSpPr>
+          <p:cNvPr id="6" name="Text 4"/>
+          <p:cNvSpPr/>
+          <p:nvPr/>
+        </p:nvSpPr>
+        <p:spPr>
+          <a:xfrm>
+            <a:off x="640080" y="4142232"/>
+            <a:ext cx="3108960" cy="822960"/>
+          </a:xfrm>
+          <a:prstGeom prst="rect">
+            <a:avLst/>
+          </a:prstGeom>
+          <a:noFill/>
+          <a:ln/>
+        </p:spPr>
+        <p:txBody>
+          <a:bodyPr wrap="square" lIns="0" tIns="0" rIns="0" bIns="0" rtlCol="0" anchor="t"/>
+          <a:lstStyle/>
+          <a:p>
+            <a:pPr indent="0" marL="0">
+              <a:buNone/>
+            </a:pPr>
+            <a:r>
+              <a:rPr lang="en-US" sz="1300" b="1" dirty="0">
+                <a:solidFill>
+                  <a:srgbClr val="1FA88F"/>
                 </a:solidFill>
                 <a:latin typeface="Courier New" pitchFamily="34" charset="0"/>
                 <a:ea typeface="Courier New" pitchFamily="34" charset="-122"/>
                 <a:cs typeface="Courier New" pitchFamily="34" charset="-120"/>
               </a:rPr>
-              <a:t>Erik Fricke · Philippos Melikidis   ·   Hochschule Reutlingen   ·   pytest · Playwright · ISO/IEC 25010</a:t>
+              <a:t>Für die Methode</a:t>
+            </a:r>
+            <a:endParaRPr lang="en-US" sz="1300" dirty="0"/>
+          </a:p>
+        </p:txBody>
+      </p:sp>
+      <p:sp>
+        <p:nvSpPr>
+          <p:cNvPr id="7" name="Text 5"/>
+          <p:cNvSpPr/>
+          <p:nvPr/>
+        </p:nvSpPr>
+        <p:spPr>
+          <a:xfrm>
+            <a:off x="3840480" y="4123944"/>
+            <a:ext cx="7680960" cy="822960"/>
+          </a:xfrm>
+          <a:prstGeom prst="rect">
+            <a:avLst/>
+          </a:prstGeom>
+          <a:noFill/>
+          <a:ln/>
+        </p:spPr>
+        <p:txBody>
+          <a:bodyPr wrap="square" lIns="0" tIns="0" rIns="0" bIns="0" rtlCol="0" anchor="ctr"/>
+          <a:lstStyle/>
+          <a:p>
+            <a:pPr indent="0" marL="0">
+              <a:lnSpc>
+                <a:spcPts val="2100"/>
+              </a:lnSpc>
+              <a:buNone/>
+            </a:pPr>
+            <a:r>
+              <a:rPr lang="en-US" sz="1550" dirty="0">
+                <a:solidFill>
+                  <a:srgbClr val="9AA7B4"/>
+                </a:solidFill>
+                <a:latin typeface="Calibri" pitchFamily="34" charset="0"/>
+                <a:ea typeface="Calibri" pitchFamily="34" charset="-122"/>
+                <a:cs typeface="Calibri" pitchFamily="34" charset="-120"/>
+              </a:rPr>
+              <a:t>Erdung über eine Crawler-Karte war hier kein Hebel. Der Agent explorierte selbst gut genug.</a:t>
+            </a:r>
+            <a:endParaRPr lang="en-US" sz="1550" dirty="0"/>
+          </a:p>
+        </p:txBody>
+      </p:sp>
+      <p:sp>
+        <p:nvSpPr>
+          <p:cNvPr id="8" name="Text 6"/>
+          <p:cNvSpPr/>
+          <p:nvPr/>
+        </p:nvSpPr>
+        <p:spPr>
+          <a:xfrm>
+            <a:off x="640080" y="5129784"/>
+            <a:ext cx="3108960" cy="822960"/>
+          </a:xfrm>
+          <a:prstGeom prst="rect">
+            <a:avLst/>
+          </a:prstGeom>
+          <a:noFill/>
+          <a:ln/>
+        </p:spPr>
+        <p:txBody>
+          <a:bodyPr wrap="square" lIns="0" tIns="0" rIns="0" bIns="0" rtlCol="0" anchor="t"/>
+          <a:lstStyle/>
+          <a:p>
+            <a:pPr indent="0" marL="0">
+              <a:buNone/>
+            </a:pPr>
+            <a:r>
+              <a:rPr lang="en-US" sz="1300" b="1" dirty="0">
+                <a:solidFill>
+                  <a:srgbClr val="1FA88F"/>
+                </a:solidFill>
+                <a:latin typeface="Courier New" pitchFamily="34" charset="0"/>
+                <a:ea typeface="Courier New" pitchFamily="34" charset="-122"/>
+                <a:cs typeface="Courier New" pitchFamily="34" charset="-120"/>
+              </a:rPr>
+              <a:t>Für die Messung</a:t>
+            </a:r>
+            <a:endParaRPr lang="en-US" sz="1300" dirty="0"/>
+          </a:p>
+        </p:txBody>
+      </p:sp>
+      <p:sp>
+        <p:nvSpPr>
+          <p:cNvPr id="9" name="Text 7"/>
+          <p:cNvSpPr/>
+          <p:nvPr/>
+        </p:nvSpPr>
+        <p:spPr>
+          <a:xfrm>
+            <a:off x="3840480" y="5111496"/>
+            <a:ext cx="7680960" cy="822960"/>
+          </a:xfrm>
+          <a:prstGeom prst="rect">
+            <a:avLst/>
+          </a:prstGeom>
+          <a:noFill/>
+          <a:ln/>
+        </p:spPr>
+        <p:txBody>
+          <a:bodyPr wrap="square" lIns="0" tIns="0" rIns="0" bIns="0" rtlCol="0" anchor="ctr"/>
+          <a:lstStyle/>
+          <a:p>
+            <a:pPr indent="0" marL="0">
+              <a:lnSpc>
+                <a:spcPts val="2100"/>
+              </a:lnSpc>
+              <a:buNone/>
+            </a:pPr>
+            <a:r>
+              <a:rPr lang="en-US" sz="1550" dirty="0">
+                <a:solidFill>
+                  <a:srgbClr val="9AA7B4"/>
+                </a:solidFill>
+                <a:latin typeface="Calibri" pitchFamily="34" charset="0"/>
+                <a:ea typeface="Calibri" pitchFamily="34" charset="-122"/>
+                <a:cs typeface="Calibri" pitchFamily="34" charset="-120"/>
+              </a:rPr>
+              <a:t>Pass-Rate allein ist irreführend. Erst eine mehrdimensionale, ISO-basierte Bewertung zeigt die Wahrheit.</a:t>
+            </a:r>
+            <a:endParaRPr lang="en-US" sz="1550" dirty="0"/>
+          </a:p>
+        </p:txBody>
+      </p:sp>
+    </p:spTree>
+  </p:cSld>
+  <p:clrMapOvr>
+    <a:masterClrMapping/>
+  </p:clrMapOvr>
+</p:sld>
+</file>
+
+<file path=ppt/slides/slide17.xml><?xml version="1.0" encoding="utf-8"?>
+<p:sld xmlns:a="http://schemas.openxmlformats.org/drawingml/2006/main" xmlns:r="http://schemas.openxmlformats.org/officeDocument/2006/relationships" xmlns:p="http://schemas.openxmlformats.org/presentationml/2006/main">
+  <p:cSld name="Slide 17">
+    <p:bg>
+      <p:bgPr>
+        <a:solidFill>
+          <a:srgbClr val="17202B"/>
+        </a:solidFill>
+      </p:bgPr>
+    </p:bg>
+    <p:spTree>
+      <p:nvGrpSpPr>
+        <p:cNvPr id="1" name=""/>
+        <p:cNvGrpSpPr/>
+        <p:nvPr/>
+      </p:nvGrpSpPr>
+      <p:grpSpPr>
+        <a:xfrm>
+          <a:off x="0" y="0"/>
+          <a:ext cx="0" cy="0"/>
+          <a:chOff x="0" y="0"/>
+          <a:chExt cx="0" cy="0"/>
+        </a:xfrm>
+      </p:grpSpPr>
+      <p:sp>
+        <p:nvSpPr>
+          <p:cNvPr id="2" name="Text 0"/>
+          <p:cNvSpPr/>
+          <p:nvPr/>
+        </p:nvSpPr>
+        <p:spPr>
+          <a:xfrm>
+            <a:off x="603504" y="2286000"/>
+            <a:ext cx="8229600" cy="1097280"/>
+          </a:xfrm>
+          <a:prstGeom prst="rect">
+            <a:avLst/>
+          </a:prstGeom>
+          <a:noFill/>
+          <a:ln/>
+        </p:spPr>
+        <p:txBody>
+          <a:bodyPr wrap="square" rtlCol="0" anchor="ctr"/>
+          <a:lstStyle/>
+          <a:p>
+            <a:pPr indent="0" marL="0">
+              <a:buNone/>
+            </a:pPr>
+            <a:r>
+              <a:rPr lang="en-US" sz="6600" b="1" dirty="0">
+                <a:solidFill>
+                  <a:srgbClr val="FFFFFF"/>
+                </a:solidFill>
+                <a:latin typeface="Cambria" pitchFamily="34" charset="0"/>
+                <a:ea typeface="Cambria" pitchFamily="34" charset="-122"/>
+                <a:cs typeface="Cambria" pitchFamily="34" charset="-120"/>
+              </a:rPr>
+              <a:t>Danke.</a:t>
+            </a:r>
+            <a:endParaRPr lang="en-US" sz="6600" dirty="0"/>
+          </a:p>
+        </p:txBody>
+      </p:sp>
+      <p:sp>
+        <p:nvSpPr>
+          <p:cNvPr id="3" name="Text 1"/>
+          <p:cNvSpPr/>
+          <p:nvPr/>
+        </p:nvSpPr>
+        <p:spPr>
+          <a:xfrm>
+            <a:off x="640080" y="3566160"/>
+            <a:ext cx="8229600" cy="548640"/>
+          </a:xfrm>
+          <a:prstGeom prst="rect">
+            <a:avLst/>
+          </a:prstGeom>
+          <a:noFill/>
+          <a:ln/>
+        </p:spPr>
+        <p:txBody>
+          <a:bodyPr wrap="square" rtlCol="0" anchor="ctr"/>
+          <a:lstStyle/>
+          <a:p>
+            <a:pPr indent="0" marL="0">
+              <a:buNone/>
+            </a:pPr>
+            <a:r>
+              <a:rPr lang="en-US" sz="2200" dirty="0">
+                <a:solidFill>
+                  <a:srgbClr val="FF5A3C"/>
+                </a:solidFill>
+                <a:latin typeface="Calibri" pitchFamily="34" charset="0"/>
+                <a:ea typeface="Calibri" pitchFamily="34" charset="-122"/>
+                <a:cs typeface="Calibri" pitchFamily="34" charset="-120"/>
+              </a:rPr>
+              <a:t>Fragen &amp; Diskussion</a:t>
+            </a:r>
+            <a:endParaRPr lang="en-US" sz="2200" dirty="0"/>
+          </a:p>
+        </p:txBody>
+      </p:sp>
+      <p:sp>
+        <p:nvSpPr>
+          <p:cNvPr id="4" name="Text 2"/>
+          <p:cNvSpPr/>
+          <p:nvPr/>
+        </p:nvSpPr>
+        <p:spPr>
+          <a:xfrm>
+            <a:off x="640080" y="6035040"/>
+            <a:ext cx="10972800" cy="365760"/>
+          </a:xfrm>
+          <a:prstGeom prst="rect">
+            <a:avLst/>
+          </a:prstGeom>
+          <a:noFill/>
+          <a:ln/>
+        </p:spPr>
+        <p:txBody>
+          <a:bodyPr wrap="square" rtlCol="0" anchor="ctr"/>
+          <a:lstStyle/>
+          <a:p>
+            <a:pPr indent="0" marL="0">
+              <a:buNone/>
+            </a:pPr>
+            <a:r>
+              <a:rPr lang="en-US" sz="1200" spc="100" kern="0" dirty="0">
+                <a:solidFill>
+                  <a:srgbClr val="9AA7B4"/>
+                </a:solidFill>
+                <a:latin typeface="Courier New" pitchFamily="34" charset="0"/>
+                <a:ea typeface="Courier New" pitchFamily="34" charset="-122"/>
+                <a:cs typeface="Courier New" pitchFamily="34" charset="-120"/>
+              </a:rPr>
+              <a:t>Timon Fricke · Philippos Melikidis   ·   HHZ   ·   pytest · Playwright · ISO/IEC 25010</a:t>
             </a:r>
             <a:endParaRPr lang="en-US" sz="1200" dirty="0"/>
           </a:p>

</xml_diff>